<commit_message>
docs(slides): add pseudobulk + AUCell method slides to construction deck
Two new methods slides in the data section of the technical construction deck:
- "Per-donor pseudobulk": the pseudoreplication problem (R2-M1), the fix
  (one bulk-like profile per patient), the how (group cells by donor×cell_type,
  sum raw counts, then NB GLM ~condition + BH-FDR), and the trade-off.
- "AUCell": label-free module activation scoring — why (no double-dipping,
  pre-specified gene set, R2-M2), how (rank genes, recovery curve over top ~5%,
  AUC normalised to [0,1] → 4-module vector per patient), and downstream use.
Deck now 17 slides; footers renumbered.

Co-Authored-By: Claude Opus 4.8 <noreply@anthropic.com>
</commit_message>
<xml_diff>
--- a/docs/SSc_MIM_construction_deck.pptx
+++ b/docs/SSc_MIM_construction_deck.pptx
@@ -20,6 +20,8 @@
     <p:sldId id="268" r:id="rId19"/>
     <p:sldId id="269" r:id="rId20"/>
     <p:sldId id="270" r:id="rId21"/>
+    <p:sldId id="271" r:id="rId22"/>
+    <p:sldId id="272" r:id="rId23"/>
   </p:sldIdLst>
   <p:sldSz cx="12191695" cy="6858000" type="screen4x3"/>
   <p:notesSz cx="6858000" cy="9144000"/>
@@ -7965,7 +7967,7 @@
             <a:avLst/>
           </a:prstGeom>
           <a:solidFill>
-            <a:srgbClr val="2E8B9E"/>
+            <a:srgbClr val="7E5A9E"/>
           </a:solidFill>
           <a:ln>
             <a:noFill/>
@@ -8027,11 +8029,11 @@
             <a:r>
               <a:rPr sz="1200" b="1" i="0">
                 <a:solidFill>
-                  <a:srgbClr val="2E8B9E"/>
-                </a:solidFill>
-                <a:latin typeface="Calibri"/>
-              </a:rPr>
-              <a:t>REPRODUCIBILITY</a:t>
+                  <a:srgbClr val="7E5A9E"/>
+                </a:solidFill>
+                <a:latin typeface="Calibri"/>
+              </a:rPr>
+              <a:t>DATA METHOD (1/2)</a:t>
             </a:r>
           </a:p>
           <a:p>
@@ -8050,21 +8052,181 @@
                 </a:solidFill>
                 <a:latin typeface="Calibri"/>
               </a:rPr>
-              <a:t>Scripted, tested, containerised, citable</a:t>
-            </a:r>
-          </a:p>
-        </p:txBody>
-      </p:sp>
-      <p:sp>
-        <p:nvSpPr>
-          <p:cNvPr id="6" name="Rectangle 5"/>
+              <a:t>Per-donor pseudobulk — the right unit of replication</a:t>
+            </a:r>
+          </a:p>
+        </p:txBody>
+      </p:sp>
+      <p:sp>
+        <p:nvSpPr>
+          <p:cNvPr id="6" name="TextBox 5"/>
+          <p:cNvSpPr txBox="1"/>
+          <p:nvPr/>
+        </p:nvSpPr>
+        <p:spPr>
+          <a:xfrm>
+            <a:off x="548640" y="1298448"/>
+            <a:ext cx="11064240" cy="640080"/>
+          </a:xfrm>
+          <a:prstGeom prst="rect">
+            <a:avLst/>
+          </a:prstGeom>
+          <a:noFill/>
+        </p:spPr>
+        <p:txBody>
+          <a:bodyPr wrap="square">
+            <a:spAutoFit/>
+          </a:bodyPr>
+          <a:lstStyle/>
+          <a:p>
+            <a:pPr algn="l">
+              <a:spcBef>
+                <a:spcPts val="0"/>
+              </a:spcBef>
+              <a:spcAft>
+                <a:spcPts val="600"/>
+              </a:spcAft>
+            </a:pPr>
+            <a:r>
+              <a:rPr sz="1450" b="0" i="1">
+                <a:solidFill>
+                  <a:srgbClr val="223038"/>
+                </a:solidFill>
+                <a:latin typeface="Calibri"/>
+              </a:rPr>
+              <a:t>Tens of thousands of cells, but only 4–13 patients per dataset. The biological question is about patients, not cells.</a:t>
+            </a:r>
+          </a:p>
+        </p:txBody>
+      </p:sp>
+      <p:sp>
+        <p:nvSpPr>
+          <p:cNvPr id="7" name="TextBox 6"/>
+          <p:cNvSpPr txBox="1"/>
+          <p:nvPr/>
+        </p:nvSpPr>
+        <p:spPr>
+          <a:xfrm>
+            <a:off x="548640" y="2011680"/>
+            <a:ext cx="5486400" cy="3931920"/>
+          </a:xfrm>
+          <a:prstGeom prst="rect">
+            <a:avLst/>
+          </a:prstGeom>
+          <a:noFill/>
+        </p:spPr>
+        <p:txBody>
+          <a:bodyPr wrap="square">
+            <a:spAutoFit/>
+          </a:bodyPr>
+          <a:lstStyle/>
+          <a:p>
+            <a:pPr algn="l">
+              <a:spcBef>
+                <a:spcPts val="0"/>
+              </a:spcBef>
+              <a:spcAft>
+                <a:spcPts val="700"/>
+              </a:spcAft>
+            </a:pPr>
+            <a:r>
+              <a:rPr sz="1400" b="1" i="0">
+                <a:solidFill>
+                  <a:srgbClr val="142C3A"/>
+                </a:solidFill>
+                <a:latin typeface="Calibri"/>
+              </a:rPr>
+              <a:t>The problem: pseudoreplication</a:t>
+            </a:r>
+          </a:p>
+          <a:p>
+            <a:pPr algn="l">
+              <a:spcBef>
+                <a:spcPts val="0"/>
+              </a:spcBef>
+              <a:spcAft>
+                <a:spcPts val="700"/>
+              </a:spcAft>
+            </a:pPr>
+            <a:r>
+              <a:rPr sz="1400" b="0" i="0">
+                <a:solidFill>
+                  <a:srgbClr val="223038"/>
+                </a:solidFill>
+                <a:latin typeface="Calibri"/>
+              </a:rPr>
+              <a:t>Cells from one patient are not independent (same genotype, biopsy, batch).</a:t>
+            </a:r>
+          </a:p>
+          <a:p>
+            <a:pPr algn="l">
+              <a:spcBef>
+                <a:spcPts val="0"/>
+              </a:spcBef>
+              <a:spcAft>
+                <a:spcPts val="700"/>
+              </a:spcAft>
+            </a:pPr>
+            <a:r>
+              <a:rPr sz="1400" b="0" i="0">
+                <a:solidFill>
+                  <a:srgbClr val="223038"/>
+                </a:solidFill>
+                <a:latin typeface="Calibri"/>
+              </a:rPr>
+              <a:t>Testing per-cell treats them as thousands of samples → inflated power, many false positives (reviewer R2-M1).</a:t>
+            </a:r>
+          </a:p>
+          <a:p>
+            <a:pPr algn="l">
+              <a:spcBef>
+                <a:spcPts val="0"/>
+              </a:spcBef>
+              <a:spcAft>
+                <a:spcPts val="700"/>
+              </a:spcAft>
+            </a:pPr>
+            <a:r>
+              <a:rPr sz="1400" b="1" i="0">
+                <a:solidFill>
+                  <a:srgbClr val="142C3A"/>
+                </a:solidFill>
+                <a:latin typeface="Calibri"/>
+              </a:rPr>
+              <a:t>The fix</a:t>
+            </a:r>
+          </a:p>
+          <a:p>
+            <a:pPr algn="l">
+              <a:spcBef>
+                <a:spcPts val="0"/>
+              </a:spcBef>
+              <a:spcAft>
+                <a:spcPts val="700"/>
+              </a:spcAft>
+            </a:pPr>
+            <a:r>
+              <a:rPr sz="1400" b="0" i="0">
+                <a:solidFill>
+                  <a:srgbClr val="223038"/>
+                </a:solidFill>
+                <a:latin typeface="Calibri"/>
+              </a:rPr>
+              <a:t>Rebuild one bulk-like profile per patient → the unit of replication becomes the patient, the correct level for SSc-vs-HC.</a:t>
+            </a:r>
+          </a:p>
+        </p:txBody>
+      </p:sp>
+      <p:sp>
+        <p:nvSpPr>
+          <p:cNvPr id="8" name="Rectangle 7"/>
           <p:cNvSpPr/>
           <p:nvPr/>
         </p:nvSpPr>
         <p:spPr>
           <a:xfrm>
-            <a:off x="548640" y="1508760"/>
-            <a:ext cx="3611880" cy="2103120"/>
+            <a:off x="6355080" y="1554480"/>
+            <a:ext cx="5257800" cy="4114800"/>
           </a:xfrm>
           <a:prstGeom prst="rect">
             <a:avLst/>
@@ -8101,461 +8263,14 @@
       </p:sp>
       <p:sp>
         <p:nvSpPr>
-          <p:cNvPr id="7" name="Rectangle 6"/>
-          <p:cNvSpPr/>
-          <p:nvPr/>
-        </p:nvSpPr>
-        <p:spPr>
-          <a:xfrm>
-            <a:off x="548640" y="1508760"/>
-            <a:ext cx="3611880" cy="73152"/>
-          </a:xfrm>
-          <a:prstGeom prst="rect">
-            <a:avLst/>
-          </a:prstGeom>
-          <a:solidFill>
-            <a:srgbClr val="3A73B8"/>
-          </a:solidFill>
-          <a:ln>
-            <a:noFill/>
-          </a:ln>
-          <a:effectLst/>
-        </p:spPr>
-        <p:style>
-          <a:lnRef idx="1">
-            <a:schemeClr val="accent1"/>
-          </a:lnRef>
-          <a:fillRef idx="3">
-            <a:schemeClr val="accent1"/>
-          </a:fillRef>
-          <a:effectRef idx="2">
-            <a:schemeClr val="accent1"/>
-          </a:effectRef>
-          <a:fontRef idx="minor">
-            <a:schemeClr val="lt1"/>
-          </a:fontRef>
-        </p:style>
-        <p:txBody>
-          <a:bodyPr rtlCol="0" anchor="ctr"/>
-          <a:lstStyle/>
-          <a:p>
-            <a:pPr algn="ctr"/>
-          </a:p>
-        </p:txBody>
-      </p:sp>
-      <p:sp>
-        <p:nvSpPr>
-          <p:cNvPr id="8" name="TextBox 7"/>
-          <p:cNvSpPr txBox="1"/>
-          <p:nvPr/>
-        </p:nvSpPr>
-        <p:spPr>
-          <a:xfrm>
-            <a:off x="749808" y="1673351"/>
-            <a:ext cx="3246120" cy="1828800"/>
-          </a:xfrm>
-          <a:prstGeom prst="rect">
-            <a:avLst/>
-          </a:prstGeom>
-          <a:noFill/>
-        </p:spPr>
-        <p:txBody>
-          <a:bodyPr wrap="square">
-            <a:spAutoFit/>
-          </a:bodyPr>
-          <a:lstStyle/>
-          <a:p>
-            <a:pPr algn="l">
-              <a:spcBef>
-                <a:spcPts val="0"/>
-              </a:spcBef>
-              <a:spcAft>
-                <a:spcPts val="500"/>
-              </a:spcAft>
-            </a:pPr>
-            <a:r>
-              <a:rPr sz="1500" b="1" i="0">
-                <a:solidFill>
-                  <a:srgbClr val="3A73B8"/>
-                </a:solidFill>
-                <a:latin typeface="Calibri"/>
-              </a:rPr>
-              <a:t>Scripted pipeline</a:t>
-            </a:r>
-          </a:p>
-          <a:p>
-            <a:pPr algn="l">
-              <a:spcBef>
-                <a:spcPts val="0"/>
-              </a:spcBef>
-              <a:spcAft>
-                <a:spcPts val="600"/>
-              </a:spcAft>
-            </a:pPr>
-            <a:r>
-              <a:rPr sz="1250" b="0" i="0">
-                <a:solidFill>
-                  <a:srgbClr val="223038"/>
-                </a:solidFill>
-                <a:latin typeface="Calibri"/>
-              </a:rPr>
-              <a:t>make auto runs the whole lane; make lint / validate run every content + SBML linter.</a:t>
-            </a:r>
-          </a:p>
-        </p:txBody>
-      </p:sp>
-      <p:sp>
-        <p:nvSpPr>
           <p:cNvPr id="9" name="Rectangle 8"/>
           <p:cNvSpPr/>
           <p:nvPr/>
         </p:nvSpPr>
         <p:spPr>
           <a:xfrm>
-            <a:off x="4315968" y="1508760"/>
-            <a:ext cx="3611880" cy="2103120"/>
-          </a:xfrm>
-          <a:prstGeom prst="rect">
-            <a:avLst/>
-          </a:prstGeom>
-          <a:solidFill>
-            <a:srgbClr val="FFFFFF"/>
-          </a:solidFill>
-          <a:ln>
-            <a:noFill/>
-          </a:ln>
-          <a:effectLst/>
-        </p:spPr>
-        <p:style>
-          <a:lnRef idx="1">
-            <a:schemeClr val="accent1"/>
-          </a:lnRef>
-          <a:fillRef idx="3">
-            <a:schemeClr val="accent1"/>
-          </a:fillRef>
-          <a:effectRef idx="2">
-            <a:schemeClr val="accent1"/>
-          </a:effectRef>
-          <a:fontRef idx="minor">
-            <a:schemeClr val="lt1"/>
-          </a:fontRef>
-        </p:style>
-        <p:txBody>
-          <a:bodyPr rtlCol="0" anchor="ctr"/>
-          <a:lstStyle/>
-          <a:p>
-            <a:pPr algn="ctr"/>
-          </a:p>
-        </p:txBody>
-      </p:sp>
-      <p:sp>
-        <p:nvSpPr>
-          <p:cNvPr id="10" name="Rectangle 9"/>
-          <p:cNvSpPr/>
-          <p:nvPr/>
-        </p:nvSpPr>
-        <p:spPr>
-          <a:xfrm>
-            <a:off x="4315968" y="1508760"/>
-            <a:ext cx="3611880" cy="73152"/>
-          </a:xfrm>
-          <a:prstGeom prst="rect">
-            <a:avLst/>
-          </a:prstGeom>
-          <a:solidFill>
-            <a:srgbClr val="3F9E8C"/>
-          </a:solidFill>
-          <a:ln>
-            <a:noFill/>
-          </a:ln>
-          <a:effectLst/>
-        </p:spPr>
-        <p:style>
-          <a:lnRef idx="1">
-            <a:schemeClr val="accent1"/>
-          </a:lnRef>
-          <a:fillRef idx="3">
-            <a:schemeClr val="accent1"/>
-          </a:fillRef>
-          <a:effectRef idx="2">
-            <a:schemeClr val="accent1"/>
-          </a:effectRef>
-          <a:fontRef idx="minor">
-            <a:schemeClr val="lt1"/>
-          </a:fontRef>
-        </p:style>
-        <p:txBody>
-          <a:bodyPr rtlCol="0" anchor="ctr"/>
-          <a:lstStyle/>
-          <a:p>
-            <a:pPr algn="ctr"/>
-          </a:p>
-        </p:txBody>
-      </p:sp>
-      <p:sp>
-        <p:nvSpPr>
-          <p:cNvPr id="11" name="TextBox 10"/>
-          <p:cNvSpPr txBox="1"/>
-          <p:nvPr/>
-        </p:nvSpPr>
-        <p:spPr>
-          <a:xfrm>
-            <a:off x="4517136" y="1673351"/>
-            <a:ext cx="3246120" cy="1828800"/>
-          </a:xfrm>
-          <a:prstGeom prst="rect">
-            <a:avLst/>
-          </a:prstGeom>
-          <a:noFill/>
-        </p:spPr>
-        <p:txBody>
-          <a:bodyPr wrap="square">
-            <a:spAutoFit/>
-          </a:bodyPr>
-          <a:lstStyle/>
-          <a:p>
-            <a:pPr algn="l">
-              <a:spcBef>
-                <a:spcPts val="0"/>
-              </a:spcBef>
-              <a:spcAft>
-                <a:spcPts val="500"/>
-              </a:spcAft>
-            </a:pPr>
-            <a:r>
-              <a:rPr sz="1500" b="1" i="0">
-                <a:solidFill>
-                  <a:srgbClr val="3F9E8C"/>
-                </a:solidFill>
-                <a:latin typeface="Calibri"/>
-              </a:rPr>
-              <a:t>Tested + CI</a:t>
-            </a:r>
-          </a:p>
-          <a:p>
-            <a:pPr algn="l">
-              <a:spcBef>
-                <a:spcPts val="0"/>
-              </a:spcBef>
-              <a:spcAft>
-                <a:spcPts val="600"/>
-              </a:spcAft>
-            </a:pPr>
-            <a:r>
-              <a:rPr sz="1250" b="0" i="0">
-                <a:solidFill>
-                  <a:srgbClr val="223038"/>
-                </a:solidFill>
-                <a:latin typeface="Calibri"/>
-              </a:rPr>
-              <a:t>pytest suite (no data needed); GitHub Actions: validate_sbml, lint, scripts-smoke, figures.</a:t>
-            </a:r>
-          </a:p>
-        </p:txBody>
-      </p:sp>
-      <p:sp>
-        <p:nvSpPr>
-          <p:cNvPr id="12" name="Rectangle 11"/>
-          <p:cNvSpPr/>
-          <p:nvPr/>
-        </p:nvSpPr>
-        <p:spPr>
-          <a:xfrm>
-            <a:off x="8083296" y="1508760"/>
-            <a:ext cx="3611880" cy="2103120"/>
-          </a:xfrm>
-          <a:prstGeom prst="rect">
-            <a:avLst/>
-          </a:prstGeom>
-          <a:solidFill>
-            <a:srgbClr val="FFFFFF"/>
-          </a:solidFill>
-          <a:ln>
-            <a:noFill/>
-          </a:ln>
-          <a:effectLst/>
-        </p:spPr>
-        <p:style>
-          <a:lnRef idx="1">
-            <a:schemeClr val="accent1"/>
-          </a:lnRef>
-          <a:fillRef idx="3">
-            <a:schemeClr val="accent1"/>
-          </a:fillRef>
-          <a:effectRef idx="2">
-            <a:schemeClr val="accent1"/>
-          </a:effectRef>
-          <a:fontRef idx="minor">
-            <a:schemeClr val="lt1"/>
-          </a:fontRef>
-        </p:style>
-        <p:txBody>
-          <a:bodyPr rtlCol="0" anchor="ctr"/>
-          <a:lstStyle/>
-          <a:p>
-            <a:pPr algn="ctr"/>
-          </a:p>
-        </p:txBody>
-      </p:sp>
-      <p:sp>
-        <p:nvSpPr>
-          <p:cNvPr id="13" name="Rectangle 12"/>
-          <p:cNvSpPr/>
-          <p:nvPr/>
-        </p:nvSpPr>
-        <p:spPr>
-          <a:xfrm>
-            <a:off x="8083296" y="1508760"/>
-            <a:ext cx="3611880" cy="73152"/>
-          </a:xfrm>
-          <a:prstGeom prst="rect">
-            <a:avLst/>
-          </a:prstGeom>
-          <a:solidFill>
-            <a:srgbClr val="2E8B9E"/>
-          </a:solidFill>
-          <a:ln>
-            <a:noFill/>
-          </a:ln>
-          <a:effectLst/>
-        </p:spPr>
-        <p:style>
-          <a:lnRef idx="1">
-            <a:schemeClr val="accent1"/>
-          </a:lnRef>
-          <a:fillRef idx="3">
-            <a:schemeClr val="accent1"/>
-          </a:fillRef>
-          <a:effectRef idx="2">
-            <a:schemeClr val="accent1"/>
-          </a:effectRef>
-          <a:fontRef idx="minor">
-            <a:schemeClr val="lt1"/>
-          </a:fontRef>
-        </p:style>
-        <p:txBody>
-          <a:bodyPr rtlCol="0" anchor="ctr"/>
-          <a:lstStyle/>
-          <a:p>
-            <a:pPr algn="ctr"/>
-          </a:p>
-        </p:txBody>
-      </p:sp>
-      <p:sp>
-        <p:nvSpPr>
-          <p:cNvPr id="14" name="TextBox 13"/>
-          <p:cNvSpPr txBox="1"/>
-          <p:nvPr/>
-        </p:nvSpPr>
-        <p:spPr>
-          <a:xfrm>
-            <a:off x="8284464" y="1673351"/>
-            <a:ext cx="3246120" cy="1828800"/>
-          </a:xfrm>
-          <a:prstGeom prst="rect">
-            <a:avLst/>
-          </a:prstGeom>
-          <a:noFill/>
-        </p:spPr>
-        <p:txBody>
-          <a:bodyPr wrap="square">
-            <a:spAutoFit/>
-          </a:bodyPr>
-          <a:lstStyle/>
-          <a:p>
-            <a:pPr algn="l">
-              <a:spcBef>
-                <a:spcPts val="0"/>
-              </a:spcBef>
-              <a:spcAft>
-                <a:spcPts val="500"/>
-              </a:spcAft>
-            </a:pPr>
-            <a:r>
-              <a:rPr sz="1500" b="1" i="0">
-                <a:solidFill>
-                  <a:srgbClr val="2E8B9E"/>
-                </a:solidFill>
-                <a:latin typeface="Calibri"/>
-              </a:rPr>
-              <a:t>Containerised</a:t>
-            </a:r>
-          </a:p>
-          <a:p>
-            <a:pPr algn="l">
-              <a:spcBef>
-                <a:spcPts val="0"/>
-              </a:spcBef>
-              <a:spcAft>
-                <a:spcPts val="600"/>
-              </a:spcAft>
-            </a:pPr>
-            <a:r>
-              <a:rPr sz="1250" b="0" i="0">
-                <a:solidFill>
-                  <a:srgbClr val="223038"/>
-                </a:solidFill>
-                <a:latin typeface="Calibri"/>
-              </a:rPr>
-              <a:t>Dockerfile + workflow pin the environment for end-to-end reproduction.</a:t>
-            </a:r>
-          </a:p>
-        </p:txBody>
-      </p:sp>
-      <p:sp>
-        <p:nvSpPr>
-          <p:cNvPr id="15" name="Rectangle 14"/>
-          <p:cNvSpPr/>
-          <p:nvPr/>
-        </p:nvSpPr>
-        <p:spPr>
-          <a:xfrm>
-            <a:off x="548640" y="3794760"/>
-            <a:ext cx="3611880" cy="2103120"/>
-          </a:xfrm>
-          <a:prstGeom prst="rect">
-            <a:avLst/>
-          </a:prstGeom>
-          <a:solidFill>
-            <a:srgbClr val="FFFFFF"/>
-          </a:solidFill>
-          <a:ln>
-            <a:noFill/>
-          </a:ln>
-          <a:effectLst/>
-        </p:spPr>
-        <p:style>
-          <a:lnRef idx="1">
-            <a:schemeClr val="accent1"/>
-          </a:lnRef>
-          <a:fillRef idx="3">
-            <a:schemeClr val="accent1"/>
-          </a:fillRef>
-          <a:effectRef idx="2">
-            <a:schemeClr val="accent1"/>
-          </a:effectRef>
-          <a:fontRef idx="minor">
-            <a:schemeClr val="lt1"/>
-          </a:fontRef>
-        </p:style>
-        <p:txBody>
-          <a:bodyPr rtlCol="0" anchor="ctr"/>
-          <a:lstStyle/>
-          <a:p>
-            <a:pPr algn="ctr"/>
-          </a:p>
-        </p:txBody>
-      </p:sp>
-      <p:sp>
-        <p:nvSpPr>
-          <p:cNvPr id="16" name="Rectangle 15"/>
-          <p:cNvSpPr/>
-          <p:nvPr/>
-        </p:nvSpPr>
-        <p:spPr>
-          <a:xfrm>
-            <a:off x="548640" y="3794760"/>
-            <a:ext cx="3611880" cy="73152"/>
+            <a:off x="6355080" y="1554480"/>
+            <a:ext cx="5257800" cy="82296"/>
           </a:xfrm>
           <a:prstGeom prst="rect">
             <a:avLst/>
@@ -8592,14 +8307,14 @@
       </p:sp>
       <p:sp>
         <p:nvSpPr>
-          <p:cNvPr id="17" name="TextBox 16"/>
+          <p:cNvPr id="10" name="TextBox 9"/>
           <p:cNvSpPr txBox="1"/>
           <p:nvPr/>
         </p:nvSpPr>
         <p:spPr>
           <a:xfrm>
-            <a:off x="749808" y="3959352"/>
-            <a:ext cx="3246120" cy="1828800"/>
+            <a:off x="6629400" y="1755648"/>
+            <a:ext cx="4754880" cy="4114800"/>
           </a:xfrm>
           <a:prstGeom prst="rect">
             <a:avLst/>
@@ -8617,138 +8332,145 @@
                 <a:spcPts val="0"/>
               </a:spcBef>
               <a:spcAft>
-                <a:spcPts val="500"/>
-              </a:spcAft>
-            </a:pPr>
-            <a:r>
-              <a:rPr sz="1500" b="1" i="0">
-                <a:solidFill>
-                  <a:srgbClr val="7E5A9E"/>
-                </a:solidFill>
-                <a:latin typeface="Calibri"/>
-              </a:rPr>
-              <a:t>Provenance &amp; metadata</a:t>
-            </a:r>
-          </a:p>
-          <a:p>
-            <a:pPr algn="l">
-              <a:spcBef>
-                <a:spcPts val="0"/>
-              </a:spcBef>
-              <a:spcAft>
                 <a:spcPts val="600"/>
               </a:spcAft>
             </a:pPr>
             <a:r>
-              <a:rPr sz="1250" b="0" i="0">
+              <a:rPr sz="1200" b="0" i="0">
                 <a:solidFill>
                   <a:srgbClr val="223038"/>
                 </a:solidFill>
-                <a:latin typeface="Calibri"/>
-              </a:rPr>
-              <a:t>RO-Crate manifest, MIRIAM injection for BioModels, CITATION.cff + .zenodo.json.</a:t>
-            </a:r>
-          </a:p>
-        </p:txBody>
-      </p:sp>
-      <p:sp>
-        <p:nvSpPr>
-          <p:cNvPr id="18" name="Rectangle 17"/>
-          <p:cNvSpPr/>
-          <p:nvPr/>
-        </p:nvSpPr>
-        <p:spPr>
-          <a:xfrm>
-            <a:off x="4315968" y="3794760"/>
-            <a:ext cx="3611880" cy="2103120"/>
-          </a:xfrm>
-          <a:prstGeom prst="rect">
-            <a:avLst/>
-          </a:prstGeom>
-          <a:solidFill>
-            <a:srgbClr val="FFFFFF"/>
-          </a:solidFill>
-          <a:ln>
-            <a:noFill/>
-          </a:ln>
-          <a:effectLst/>
-        </p:spPr>
-        <p:style>
-          <a:lnRef idx="1">
-            <a:schemeClr val="accent1"/>
-          </a:lnRef>
-          <a:fillRef idx="3">
-            <a:schemeClr val="accent1"/>
-          </a:fillRef>
-          <a:effectRef idx="2">
-            <a:schemeClr val="accent1"/>
-          </a:effectRef>
-          <a:fontRef idx="minor">
-            <a:schemeClr val="lt1"/>
-          </a:fontRef>
-        </p:style>
-        <p:txBody>
-          <a:bodyPr rtlCol="0" anchor="ctr"/>
-          <a:lstStyle/>
-          <a:p>
-            <a:pPr algn="ctr"/>
-          </a:p>
-        </p:txBody>
-      </p:sp>
-      <p:sp>
-        <p:nvSpPr>
-          <p:cNvPr id="19" name="Rectangle 18"/>
-          <p:cNvSpPr/>
-          <p:nvPr/>
-        </p:nvSpPr>
-        <p:spPr>
-          <a:xfrm>
-            <a:off x="4315968" y="3794760"/>
-            <a:ext cx="3611880" cy="73152"/>
-          </a:xfrm>
-          <a:prstGeom prst="rect">
-            <a:avLst/>
-          </a:prstGeom>
-          <a:solidFill>
-            <a:srgbClr val="E26D5A"/>
-          </a:solidFill>
-          <a:ln>
-            <a:noFill/>
-          </a:ln>
-          <a:effectLst/>
-        </p:spPr>
-        <p:style>
-          <a:lnRef idx="1">
-            <a:schemeClr val="accent1"/>
-          </a:lnRef>
-          <a:fillRef idx="3">
-            <a:schemeClr val="accent1"/>
-          </a:fillRef>
-          <a:effectRef idx="2">
-            <a:schemeClr val="accent1"/>
-          </a:effectRef>
-          <a:fontRef idx="minor">
-            <a:schemeClr val="lt1"/>
-          </a:fontRef>
-        </p:style>
-        <p:txBody>
-          <a:bodyPr rtlCol="0" anchor="ctr"/>
-          <a:lstStyle/>
-          <a:p>
-            <a:pPr algn="ctr"/>
-          </a:p>
-        </p:txBody>
-      </p:sp>
-      <p:sp>
-        <p:nvSpPr>
-          <p:cNvPr id="20" name="TextBox 19"/>
+                <a:latin typeface="Consolas"/>
+              </a:rPr>
+              <a:t>group cells by (donor × cell_type)</a:t>
+            </a:r>
+          </a:p>
+          <a:p>
+            <a:pPr algn="l">
+              <a:spcBef>
+                <a:spcPts val="0"/>
+              </a:spcBef>
+              <a:spcAft>
+                <a:spcPts val="600"/>
+              </a:spcAft>
+            </a:pPr>
+            <a:r>
+              <a:rPr sz="1200" b="0" i="0">
+                <a:solidFill>
+                  <a:srgbClr val="223038"/>
+                </a:solidFill>
+                <a:latin typeface="Consolas"/>
+              </a:rPr>
+              <a:t>row[gene] = Σ raw counts over cells</a:t>
+            </a:r>
+          </a:p>
+          <a:p>
+            <a:pPr algn="l">
+              <a:spcBef>
+                <a:spcPts val="0"/>
+              </a:spcBef>
+              <a:spcAft>
+                <a:spcPts val="600"/>
+              </a:spcAft>
+            </a:pPr>
+            <a:r>
+              <a:rPr sz="1300" b="0" i="0">
+                <a:solidFill>
+                  <a:srgbClr val="223038"/>
+                </a:solidFill>
+                <a:latin typeface="Calibri"/>
+              </a:rPr>
+              <a:t>→ one pseudobulk count row per (donor, cell type).</a:t>
+            </a:r>
+          </a:p>
+          <a:p>
+            <a:pPr algn="l">
+              <a:spcBef>
+                <a:spcPts val="0"/>
+              </a:spcBef>
+              <a:spcAft>
+                <a:spcPts val="600"/>
+              </a:spcAft>
+            </a:pPr>
+            <a:r>
+              <a:rPr sz="1300" b="1" i="0">
+                <a:solidFill>
+                  <a:srgbClr val="142C3A"/>
+                </a:solidFill>
+                <a:latin typeface="Calibri"/>
+              </a:rPr>
+              <a:t>Then DEG on the pseudobulks</a:t>
+            </a:r>
+          </a:p>
+          <a:p>
+            <a:pPr algn="l">
+              <a:spcBef>
+                <a:spcPts val="0"/>
+              </a:spcBef>
+              <a:spcAft>
+                <a:spcPts val="600"/>
+              </a:spcAft>
+            </a:pPr>
+            <a:r>
+              <a:rPr sz="1200" b="0" i="0">
+                <a:solidFill>
+                  <a:srgbClr val="223038"/>
+                </a:solidFill>
+                <a:latin typeface="Consolas"/>
+              </a:rPr>
+              <a:t>NB GLM (pydeseq2) ~ condition</a:t>
+            </a:r>
+          </a:p>
+          <a:p>
+            <a:pPr algn="l">
+              <a:spcBef>
+                <a:spcPts val="0"/>
+              </a:spcBef>
+              <a:spcAft>
+                <a:spcPts val="600"/>
+              </a:spcAft>
+            </a:pPr>
+            <a:r>
+              <a:rPr sz="1200" b="0" i="0">
+                <a:solidFill>
+                  <a:srgbClr val="223038"/>
+                </a:solidFill>
+                <a:latin typeface="Consolas"/>
+              </a:rPr>
+              <a:t>+ Benjamini-Hochberg FDR (q=0.05)</a:t>
+            </a:r>
+          </a:p>
+          <a:p>
+            <a:pPr algn="l">
+              <a:spcBef>
+                <a:spcPts val="0"/>
+              </a:spcBef>
+              <a:spcAft>
+                <a:spcPts val="600"/>
+              </a:spcAft>
+            </a:pPr>
+            <a:r>
+              <a:rPr sz="1300" b="0" i="0">
+                <a:solidFill>
+                  <a:srgbClr val="223038"/>
+                </a:solidFill>
+                <a:latin typeface="Calibri"/>
+              </a:rPr>
+              <a:t>Raw counts (not log) — the NB GLM models depth &amp; overdispersion itself.</a:t>
+            </a:r>
+          </a:p>
+        </p:txBody>
+      </p:sp>
+      <p:sp>
+        <p:nvSpPr>
+          <p:cNvPr id="11" name="TextBox 10"/>
           <p:cNvSpPr txBox="1"/>
           <p:nvPr/>
         </p:nvSpPr>
         <p:spPr>
           <a:xfrm>
-            <a:off x="4517136" y="3959352"/>
-            <a:ext cx="3246120" cy="1828800"/>
+            <a:off x="548640" y="5989320"/>
+            <a:ext cx="11064240" cy="548640"/>
           </a:xfrm>
           <a:prstGeom prst="rect">
             <a:avLst/>
@@ -8766,138 +8488,31 @@
                 <a:spcPts val="0"/>
               </a:spcBef>
               <a:spcAft>
-                <a:spcPts val="500"/>
-              </a:spcAft>
-            </a:pPr>
-            <a:r>
-              <a:rPr sz="1500" b="1" i="0">
-                <a:solidFill>
-                  <a:srgbClr val="E26D5A"/>
-                </a:solidFill>
-                <a:latin typeface="Calibri"/>
-              </a:rPr>
-              <a:t>Input-data mirror</a:t>
-            </a:r>
-          </a:p>
-          <a:p>
-            <a:pPr algn="l">
-              <a:spcBef>
-                <a:spcPts val="0"/>
-              </a:spcBef>
-              <a:spcAft>
                 <a:spcPts val="600"/>
               </a:spcAft>
             </a:pPr>
             <a:r>
-              <a:rPr sz="1250" b="0" i="0">
-                <a:solidFill>
-                  <a:srgbClr val="223038"/>
-                </a:solidFill>
-                <a:latin typeface="Calibri"/>
-              </a:rPr>
-              <a:t>data/MIRROR.md + .sha256 — SHA-256-pinned GEO archives (Zenodo mirror).</a:t>
-            </a:r>
-          </a:p>
-        </p:txBody>
-      </p:sp>
-      <p:sp>
-        <p:nvSpPr>
-          <p:cNvPr id="21" name="Rectangle 20"/>
-          <p:cNvSpPr/>
-          <p:nvPr/>
-        </p:nvSpPr>
-        <p:spPr>
-          <a:xfrm>
-            <a:off x="8083296" y="3794760"/>
-            <a:ext cx="3611880" cy="2103120"/>
-          </a:xfrm>
-          <a:prstGeom prst="rect">
-            <a:avLst/>
-          </a:prstGeom>
-          <a:solidFill>
-            <a:srgbClr val="FFFFFF"/>
-          </a:solidFill>
-          <a:ln>
-            <a:noFill/>
-          </a:ln>
-          <a:effectLst/>
-        </p:spPr>
-        <p:style>
-          <a:lnRef idx="1">
-            <a:schemeClr val="accent1"/>
-          </a:lnRef>
-          <a:fillRef idx="3">
-            <a:schemeClr val="accent1"/>
-          </a:fillRef>
-          <a:effectRef idx="2">
-            <a:schemeClr val="accent1"/>
-          </a:effectRef>
-          <a:fontRef idx="minor">
-            <a:schemeClr val="lt1"/>
-          </a:fontRef>
-        </p:style>
-        <p:txBody>
-          <a:bodyPr rtlCol="0" anchor="ctr"/>
-          <a:lstStyle/>
-          <a:p>
-            <a:pPr algn="ctr"/>
-          </a:p>
-        </p:txBody>
-      </p:sp>
-      <p:sp>
-        <p:nvSpPr>
-          <p:cNvPr id="22" name="Rectangle 21"/>
-          <p:cNvSpPr/>
-          <p:nvPr/>
-        </p:nvSpPr>
-        <p:spPr>
-          <a:xfrm>
-            <a:off x="8083296" y="3794760"/>
-            <a:ext cx="3611880" cy="73152"/>
-          </a:xfrm>
-          <a:prstGeom prst="rect">
-            <a:avLst/>
-          </a:prstGeom>
-          <a:solidFill>
-            <a:srgbClr val="142C3A"/>
-          </a:solidFill>
-          <a:ln>
-            <a:noFill/>
-          </a:ln>
-          <a:effectLst/>
-        </p:spPr>
-        <p:style>
-          <a:lnRef idx="1">
-            <a:schemeClr val="accent1"/>
-          </a:lnRef>
-          <a:fillRef idx="3">
-            <a:schemeClr val="accent1"/>
-          </a:fillRef>
-          <a:effectRef idx="2">
-            <a:schemeClr val="accent1"/>
-          </a:effectRef>
-          <a:fontRef idx="minor">
-            <a:schemeClr val="lt1"/>
-          </a:fontRef>
-        </p:style>
-        <p:txBody>
-          <a:bodyPr rtlCol="0" anchor="ctr"/>
-          <a:lstStyle/>
-          <a:p>
-            <a:pPr algn="ctr"/>
-          </a:p>
-        </p:txBody>
-      </p:sp>
-      <p:sp>
-        <p:nvSpPr>
-          <p:cNvPr id="23" name="TextBox 22"/>
+              <a:rPr sz="1250" b="0" i="1">
+                <a:solidFill>
+                  <a:srgbClr val="6B7A82"/>
+                </a:solidFill>
+                <a:latin typeface="Calibri"/>
+              </a:rPr>
+              <a:t>Trade-off: fewer, more robust hits. Less cell-level granularity, but a valid, reproducible inference — and the same pseudobulks feed AUCell.</a:t>
+            </a:r>
+          </a:p>
+        </p:txBody>
+      </p:sp>
+      <p:sp>
+        <p:nvSpPr>
+          <p:cNvPr id="12" name="TextBox 11"/>
           <p:cNvSpPr txBox="1"/>
           <p:nvPr/>
         </p:nvSpPr>
         <p:spPr>
           <a:xfrm>
-            <a:off x="8284464" y="3959352"/>
-            <a:ext cx="3246120" cy="1828800"/>
+            <a:off x="548640" y="6437376"/>
+            <a:ext cx="8229600" cy="365760"/>
           </a:xfrm>
           <a:prstGeom prst="rect">
             <a:avLst/>
@@ -8915,71 +8530,10 @@
                 <a:spcPts val="0"/>
               </a:spcBef>
               <a:spcAft>
-                <a:spcPts val="500"/>
-              </a:spcAft>
-            </a:pPr>
-            <a:r>
-              <a:rPr sz="1500" b="1" i="0">
-                <a:solidFill>
-                  <a:srgbClr val="142C3A"/>
-                </a:solidFill>
-                <a:latin typeface="Calibri"/>
-              </a:rPr>
-              <a:t>Release</a:t>
-            </a:r>
-          </a:p>
-          <a:p>
-            <a:pPr algn="l">
-              <a:spcBef>
-                <a:spcPts val="0"/>
-              </a:spcBef>
-              <a:spcAft>
                 <a:spcPts val="600"/>
               </a:spcAft>
             </a:pPr>
             <a:r>
-              <a:rPr sz="1250" b="0" i="0">
-                <a:solidFill>
-                  <a:srgbClr val="223038"/>
-                </a:solidFill>
-                <a:latin typeface="Calibri"/>
-              </a:rPr>
-              <a:t>GitHub + Zenodo DOI at git tag v1.0; make release pre-flights.</a:t>
-            </a:r>
-          </a:p>
-        </p:txBody>
-      </p:sp>
-      <p:sp>
-        <p:nvSpPr>
-          <p:cNvPr id="24" name="TextBox 23"/>
-          <p:cNvSpPr txBox="1"/>
-          <p:nvPr/>
-        </p:nvSpPr>
-        <p:spPr>
-          <a:xfrm>
-            <a:off x="548640" y="6437376"/>
-            <a:ext cx="8229600" cy="365760"/>
-          </a:xfrm>
-          <a:prstGeom prst="rect">
-            <a:avLst/>
-          </a:prstGeom>
-          <a:noFill/>
-        </p:spPr>
-        <p:txBody>
-          <a:bodyPr wrap="square">
-            <a:spAutoFit/>
-          </a:bodyPr>
-          <a:lstStyle/>
-          <a:p>
-            <a:pPr algn="l">
-              <a:spcBef>
-                <a:spcPts val="0"/>
-              </a:spcBef>
-              <a:spcAft>
-                <a:spcPts val="600"/>
-              </a:spcAft>
-            </a:pPr>
-            <a:r>
               <a:rPr sz="900" b="0" i="0">
                 <a:solidFill>
                   <a:srgbClr val="6B7A82"/>
@@ -8993,7 +8547,7 @@
       </p:sp>
       <p:sp>
         <p:nvSpPr>
-          <p:cNvPr id="25" name="TextBox 24"/>
+          <p:cNvPr id="13" name="TextBox 12"/>
           <p:cNvSpPr txBox="1"/>
           <p:nvPr/>
         </p:nvSpPr>
@@ -9042,6 +8596,1898 @@
 </file>
 
 <file path=ppt/slides/slide15.xml><?xml version="1.0" encoding="utf-8"?>
+<p:sld xmlns:a="http://schemas.openxmlformats.org/drawingml/2006/main" xmlns:p="http://schemas.openxmlformats.org/presentationml/2006/main" xmlns:r="http://schemas.openxmlformats.org/officeDocument/2006/relationships">
+  <p:cSld>
+    <p:spTree>
+      <p:nvGrpSpPr>
+        <p:cNvPr id="1" name=""/>
+        <p:cNvGrpSpPr/>
+        <p:nvPr/>
+      </p:nvGrpSpPr>
+      <p:grpSpPr/>
+      <p:sp>
+        <p:nvSpPr>
+          <p:cNvPr id="2" name="Rectangle 1"/>
+          <p:cNvSpPr/>
+          <p:nvPr/>
+        </p:nvSpPr>
+        <p:spPr>
+          <a:xfrm>
+            <a:off x="0" y="0"/>
+            <a:ext cx="12191695" cy="6858000"/>
+          </a:xfrm>
+          <a:prstGeom prst="rect">
+            <a:avLst/>
+          </a:prstGeom>
+          <a:solidFill>
+            <a:srgbClr val="F6F4F0"/>
+          </a:solidFill>
+          <a:ln>
+            <a:noFill/>
+          </a:ln>
+          <a:effectLst/>
+        </p:spPr>
+        <p:style>
+          <a:lnRef idx="1">
+            <a:schemeClr val="accent1"/>
+          </a:lnRef>
+          <a:fillRef idx="3">
+            <a:schemeClr val="accent1"/>
+          </a:fillRef>
+          <a:effectRef idx="2">
+            <a:schemeClr val="accent1"/>
+          </a:effectRef>
+          <a:fontRef idx="minor">
+            <a:schemeClr val="lt1"/>
+          </a:fontRef>
+        </p:style>
+        <p:txBody>
+          <a:bodyPr rtlCol="0" anchor="ctr"/>
+          <a:lstStyle/>
+          <a:p>
+            <a:pPr algn="ctr"/>
+          </a:p>
+        </p:txBody>
+      </p:sp>
+      <p:sp>
+        <p:nvSpPr>
+          <p:cNvPr id="3" name="Rectangle 2"/>
+          <p:cNvSpPr/>
+          <p:nvPr/>
+        </p:nvSpPr>
+        <p:spPr>
+          <a:xfrm>
+            <a:off x="0" y="0"/>
+            <a:ext cx="12191695" cy="1078992"/>
+          </a:xfrm>
+          <a:prstGeom prst="rect">
+            <a:avLst/>
+          </a:prstGeom>
+          <a:solidFill>
+            <a:srgbClr val="142C3A"/>
+          </a:solidFill>
+          <a:ln>
+            <a:noFill/>
+          </a:ln>
+          <a:effectLst/>
+        </p:spPr>
+        <p:style>
+          <a:lnRef idx="1">
+            <a:schemeClr val="accent1"/>
+          </a:lnRef>
+          <a:fillRef idx="3">
+            <a:schemeClr val="accent1"/>
+          </a:fillRef>
+          <a:effectRef idx="2">
+            <a:schemeClr val="accent1"/>
+          </a:effectRef>
+          <a:fontRef idx="minor">
+            <a:schemeClr val="lt1"/>
+          </a:fontRef>
+        </p:style>
+        <p:txBody>
+          <a:bodyPr rtlCol="0" anchor="ctr"/>
+          <a:lstStyle/>
+          <a:p>
+            <a:pPr algn="ctr"/>
+          </a:p>
+        </p:txBody>
+      </p:sp>
+      <p:sp>
+        <p:nvSpPr>
+          <p:cNvPr id="4" name="Rectangle 3"/>
+          <p:cNvSpPr/>
+          <p:nvPr/>
+        </p:nvSpPr>
+        <p:spPr>
+          <a:xfrm>
+            <a:off x="0" y="1078992"/>
+            <a:ext cx="12191695" cy="54864"/>
+          </a:xfrm>
+          <a:prstGeom prst="rect">
+            <a:avLst/>
+          </a:prstGeom>
+          <a:solidFill>
+            <a:srgbClr val="7E5A9E"/>
+          </a:solidFill>
+          <a:ln>
+            <a:noFill/>
+          </a:ln>
+          <a:effectLst/>
+        </p:spPr>
+        <p:style>
+          <a:lnRef idx="1">
+            <a:schemeClr val="accent1"/>
+          </a:lnRef>
+          <a:fillRef idx="3">
+            <a:schemeClr val="accent1"/>
+          </a:fillRef>
+          <a:effectRef idx="2">
+            <a:schemeClr val="accent1"/>
+          </a:effectRef>
+          <a:fontRef idx="minor">
+            <a:schemeClr val="lt1"/>
+          </a:fontRef>
+        </p:style>
+        <p:txBody>
+          <a:bodyPr rtlCol="0" anchor="ctr"/>
+          <a:lstStyle/>
+          <a:p>
+            <a:pPr algn="ctr"/>
+          </a:p>
+        </p:txBody>
+      </p:sp>
+      <p:sp>
+        <p:nvSpPr>
+          <p:cNvPr id="5" name="TextBox 4"/>
+          <p:cNvSpPr txBox="1"/>
+          <p:nvPr/>
+        </p:nvSpPr>
+        <p:spPr>
+          <a:xfrm>
+            <a:off x="548640" y="109728"/>
+            <a:ext cx="11155680" cy="914400"/>
+          </a:xfrm>
+          <a:prstGeom prst="rect">
+            <a:avLst/>
+          </a:prstGeom>
+          <a:noFill/>
+        </p:spPr>
+        <p:txBody>
+          <a:bodyPr wrap="square">
+            <a:spAutoFit/>
+          </a:bodyPr>
+          <a:lstStyle/>
+          <a:p>
+            <a:pPr algn="l">
+              <a:spcBef>
+                <a:spcPts val="0"/>
+              </a:spcBef>
+              <a:spcAft>
+                <a:spcPts val="600"/>
+              </a:spcAft>
+            </a:pPr>
+            <a:r>
+              <a:rPr sz="1200" b="1" i="0">
+                <a:solidFill>
+                  <a:srgbClr val="7E5A9E"/>
+                </a:solidFill>
+                <a:latin typeface="Calibri"/>
+              </a:rPr>
+              <a:t>DATA METHOD (2/2)</a:t>
+            </a:r>
+          </a:p>
+          <a:p>
+            <a:pPr algn="l">
+              <a:spcBef>
+                <a:spcPts val="100"/>
+              </a:spcBef>
+              <a:spcAft>
+                <a:spcPts val="600"/>
+              </a:spcAft>
+            </a:pPr>
+            <a:r>
+              <a:rPr sz="2500" b="1" i="0">
+                <a:solidFill>
+                  <a:srgbClr val="FFFFFF"/>
+                </a:solidFill>
+                <a:latin typeface="Calibri"/>
+              </a:rPr>
+              <a:t>AUCell — label-free module activation scoring</a:t>
+            </a:r>
+          </a:p>
+        </p:txBody>
+      </p:sp>
+      <p:sp>
+        <p:nvSpPr>
+          <p:cNvPr id="6" name="TextBox 5"/>
+          <p:cNvSpPr txBox="1"/>
+          <p:nvPr/>
+        </p:nvSpPr>
+        <p:spPr>
+          <a:xfrm>
+            <a:off x="548640" y="1298448"/>
+            <a:ext cx="11064240" cy="640080"/>
+          </a:xfrm>
+          <a:prstGeom prst="rect">
+            <a:avLst/>
+          </a:prstGeom>
+          <a:noFill/>
+        </p:spPr>
+        <p:txBody>
+          <a:bodyPr wrap="square">
+            <a:spAutoFit/>
+          </a:bodyPr>
+          <a:lstStyle/>
+          <a:p>
+            <a:pPr algn="l">
+              <a:spcBef>
+                <a:spcPts val="0"/>
+              </a:spcBef>
+              <a:spcAft>
+                <a:spcPts val="600"/>
+              </a:spcAft>
+            </a:pPr>
+            <a:r>
+              <a:rPr sz="1450" b="0" i="1">
+                <a:solidFill>
+                  <a:srgbClr val="223038"/>
+                </a:solidFill>
+                <a:latin typeface="Calibri"/>
+              </a:rPr>
+              <a:t>“Are a module’s genes concentrated among this patient’s most highly-expressed genes?”  If yes → the module is on.</a:t>
+            </a:r>
+          </a:p>
+        </p:txBody>
+      </p:sp>
+      <p:sp>
+        <p:nvSpPr>
+          <p:cNvPr id="7" name="TextBox 6"/>
+          <p:cNvSpPr txBox="1"/>
+          <p:nvPr/>
+        </p:nvSpPr>
+        <p:spPr>
+          <a:xfrm>
+            <a:off x="548640" y="2011680"/>
+            <a:ext cx="5486400" cy="3931920"/>
+          </a:xfrm>
+          <a:prstGeom prst="rect">
+            <a:avLst/>
+          </a:prstGeom>
+          <a:noFill/>
+        </p:spPr>
+        <p:txBody>
+          <a:bodyPr wrap="square">
+            <a:spAutoFit/>
+          </a:bodyPr>
+          <a:lstStyle/>
+          <a:p>
+            <a:pPr algn="l">
+              <a:spcBef>
+                <a:spcPts val="0"/>
+              </a:spcBef>
+              <a:spcAft>
+                <a:spcPts val="700"/>
+              </a:spcAft>
+            </a:pPr>
+            <a:r>
+              <a:rPr sz="1400" b="1" i="0">
+                <a:solidFill>
+                  <a:srgbClr val="142C3A"/>
+                </a:solidFill>
+                <a:latin typeface="Calibri"/>
+              </a:rPr>
+              <a:t>Why — no double-dipping</a:t>
+            </a:r>
+          </a:p>
+          <a:p>
+            <a:pPr algn="l">
+              <a:spcBef>
+                <a:spcPts val="0"/>
+              </a:spcBef>
+              <a:spcAft>
+                <a:spcPts val="700"/>
+              </a:spcAft>
+            </a:pPr>
+            <a:r>
+              <a:rPr sz="1400" b="0" i="0">
+                <a:solidFill>
+                  <a:srgbClr val="223038"/>
+                </a:solidFill>
+                <a:latin typeface="Calibri"/>
+              </a:rPr>
+              <a:t>v1.0 weighted expression by the SSc-vs-HC sign, then tested SSc-vs-HC → circular (reviewer R2-M2).</a:t>
+            </a:r>
+          </a:p>
+          <a:p>
+            <a:pPr algn="l">
+              <a:spcBef>
+                <a:spcPts val="0"/>
+              </a:spcBef>
+              <a:spcAft>
+                <a:spcPts val="700"/>
+              </a:spcAft>
+            </a:pPr>
+            <a:r>
+              <a:rPr sz="1400" b="0" i="0">
+                <a:solidFill>
+                  <a:srgbClr val="223038"/>
+                </a:solidFill>
+                <a:latin typeface="Calibri"/>
+              </a:rPr>
+              <a:t>AUCell scores each donor against the pre-specified module gene set (from the curated map), blind to the SSc/HC label.</a:t>
+            </a:r>
+          </a:p>
+          <a:p>
+            <a:pPr algn="l">
+              <a:spcBef>
+                <a:spcPts val="0"/>
+              </a:spcBef>
+              <a:spcAft>
+                <a:spcPts val="700"/>
+              </a:spcAft>
+            </a:pPr>
+            <a:r>
+              <a:rPr sz="1400" b="1" i="0">
+                <a:solidFill>
+                  <a:srgbClr val="142C3A"/>
+                </a:solidFill>
+                <a:latin typeface="Calibri"/>
+              </a:rPr>
+              <a:t>Rank-based → robust</a:t>
+            </a:r>
+          </a:p>
+          <a:p>
+            <a:pPr algn="l">
+              <a:spcBef>
+                <a:spcPts val="0"/>
+              </a:spcBef>
+              <a:spcAft>
+                <a:spcPts val="700"/>
+              </a:spcAft>
+            </a:pPr>
+            <a:r>
+              <a:rPr sz="1400" b="0" i="0">
+                <a:solidFill>
+                  <a:srgbClr val="223038"/>
+                </a:solidFill>
+                <a:latin typeface="Calibri"/>
+              </a:rPr>
+              <a:t>Depends only on the order of genes, not absolute values → insensitive to scale, depth, normalisation.</a:t>
+            </a:r>
+          </a:p>
+        </p:txBody>
+      </p:sp>
+      <p:sp>
+        <p:nvSpPr>
+          <p:cNvPr id="8" name="Rectangle 7"/>
+          <p:cNvSpPr/>
+          <p:nvPr/>
+        </p:nvSpPr>
+        <p:spPr>
+          <a:xfrm>
+            <a:off x="6355080" y="1554480"/>
+            <a:ext cx="5257800" cy="4114800"/>
+          </a:xfrm>
+          <a:prstGeom prst="rect">
+            <a:avLst/>
+          </a:prstGeom>
+          <a:solidFill>
+            <a:srgbClr val="FFFFFF"/>
+          </a:solidFill>
+          <a:ln>
+            <a:noFill/>
+          </a:ln>
+          <a:effectLst/>
+        </p:spPr>
+        <p:style>
+          <a:lnRef idx="1">
+            <a:schemeClr val="accent1"/>
+          </a:lnRef>
+          <a:fillRef idx="3">
+            <a:schemeClr val="accent1"/>
+          </a:fillRef>
+          <a:effectRef idx="2">
+            <a:schemeClr val="accent1"/>
+          </a:effectRef>
+          <a:fontRef idx="minor">
+            <a:schemeClr val="lt1"/>
+          </a:fontRef>
+        </p:style>
+        <p:txBody>
+          <a:bodyPr rtlCol="0" anchor="ctr"/>
+          <a:lstStyle/>
+          <a:p>
+            <a:pPr algn="ctr"/>
+          </a:p>
+        </p:txBody>
+      </p:sp>
+      <p:sp>
+        <p:nvSpPr>
+          <p:cNvPr id="9" name="Rectangle 8"/>
+          <p:cNvSpPr/>
+          <p:nvPr/>
+        </p:nvSpPr>
+        <p:spPr>
+          <a:xfrm>
+            <a:off x="6355080" y="1554480"/>
+            <a:ext cx="5257800" cy="82296"/>
+          </a:xfrm>
+          <a:prstGeom prst="rect">
+            <a:avLst/>
+          </a:prstGeom>
+          <a:solidFill>
+            <a:srgbClr val="7E5A9E"/>
+          </a:solidFill>
+          <a:ln>
+            <a:noFill/>
+          </a:ln>
+          <a:effectLst/>
+        </p:spPr>
+        <p:style>
+          <a:lnRef idx="1">
+            <a:schemeClr val="accent1"/>
+          </a:lnRef>
+          <a:fillRef idx="3">
+            <a:schemeClr val="accent1"/>
+          </a:fillRef>
+          <a:effectRef idx="2">
+            <a:schemeClr val="accent1"/>
+          </a:effectRef>
+          <a:fontRef idx="minor">
+            <a:schemeClr val="lt1"/>
+          </a:fontRef>
+        </p:style>
+        <p:txBody>
+          <a:bodyPr rtlCol="0" anchor="ctr"/>
+          <a:lstStyle/>
+          <a:p>
+            <a:pPr algn="ctr"/>
+          </a:p>
+        </p:txBody>
+      </p:sp>
+      <p:sp>
+        <p:nvSpPr>
+          <p:cNvPr id="10" name="TextBox 9"/>
+          <p:cNvSpPr txBox="1"/>
+          <p:nvPr/>
+        </p:nvSpPr>
+        <p:spPr>
+          <a:xfrm>
+            <a:off x="6629400" y="1755648"/>
+            <a:ext cx="4754880" cy="4114800"/>
+          </a:xfrm>
+          <a:prstGeom prst="rect">
+            <a:avLst/>
+          </a:prstGeom>
+          <a:noFill/>
+        </p:spPr>
+        <p:txBody>
+          <a:bodyPr wrap="square">
+            <a:spAutoFit/>
+          </a:bodyPr>
+          <a:lstStyle/>
+          <a:p>
+            <a:pPr algn="l">
+              <a:spcBef>
+                <a:spcPts val="0"/>
+              </a:spcBef>
+              <a:spcAft>
+                <a:spcPts val="700"/>
+              </a:spcAft>
+            </a:pPr>
+            <a:r>
+              <a:rPr sz="1300" b="0" i="0">
+                <a:solidFill>
+                  <a:srgbClr val="223038"/>
+                </a:solidFill>
+                <a:latin typeface="Calibri"/>
+              </a:rPr>
+              <a:t>Rank all genes by expression (rank 1 = highest).</a:t>
+            </a:r>
+          </a:p>
+          <a:p>
+            <a:pPr algn="l">
+              <a:spcBef>
+                <a:spcPts val="0"/>
+              </a:spcBef>
+              <a:spcAft>
+                <a:spcPts val="700"/>
+              </a:spcAft>
+            </a:pPr>
+            <a:r>
+              <a:rPr sz="1300" b="0" i="0">
+                <a:solidFill>
+                  <a:srgbClr val="223038"/>
+                </a:solidFill>
+                <a:latin typeface="Calibri"/>
+              </a:rPr>
+              <a:t>Walk the top T (top ~5%); recovery curve R(r) = # module genes with rank ≤ r.</a:t>
+            </a:r>
+          </a:p>
+          <a:p>
+            <a:pPr algn="l">
+              <a:spcBef>
+                <a:spcPts val="0"/>
+              </a:spcBef>
+              <a:spcAft>
+                <a:spcPts val="700"/>
+              </a:spcAft>
+            </a:pPr>
+            <a:r>
+              <a:rPr sz="1200" b="0" i="0">
+                <a:solidFill>
+                  <a:srgbClr val="223038"/>
+                </a:solidFill>
+                <a:latin typeface="Consolas"/>
+              </a:rPr>
+              <a:t>AUC = Σ R(r),  normalised to [0,1]</a:t>
+            </a:r>
+          </a:p>
+          <a:p>
+            <a:pPr algn="l">
+              <a:spcBef>
+                <a:spcPts val="0"/>
+              </a:spcBef>
+              <a:spcAft>
+                <a:spcPts val="700"/>
+              </a:spcAft>
+            </a:pPr>
+            <a:r>
+              <a:rPr sz="1300" b="0" i="0">
+                <a:solidFill>
+                  <a:srgbClr val="223038"/>
+                </a:solidFill>
+                <a:latin typeface="Calibri"/>
+              </a:rPr>
+              <a:t>High AUC → module genes cluster at the top → module active.</a:t>
+            </a:r>
+          </a:p>
+          <a:p>
+            <a:pPr algn="l">
+              <a:spcBef>
+                <a:spcPts val="0"/>
+              </a:spcBef>
+              <a:spcAft>
+                <a:spcPts val="700"/>
+              </a:spcAft>
+            </a:pPr>
+            <a:r>
+              <a:rPr sz="1300" b="0" i="0">
+                <a:solidFill>
+                  <a:srgbClr val="223038"/>
+                </a:solidFill>
+                <a:latin typeface="Calibri"/>
+              </a:rPr>
+              <a:t>Output: a 4-module activation vector per patient (+ a Z-score for triangulation).</a:t>
+            </a:r>
+          </a:p>
+        </p:txBody>
+      </p:sp>
+      <p:sp>
+        <p:nvSpPr>
+          <p:cNvPr id="11" name="TextBox 10"/>
+          <p:cNvSpPr txBox="1"/>
+          <p:nvPr/>
+        </p:nvSpPr>
+        <p:spPr>
+          <a:xfrm>
+            <a:off x="548640" y="5989320"/>
+            <a:ext cx="11064240" cy="548640"/>
+          </a:xfrm>
+          <a:prstGeom prst="rect">
+            <a:avLst/>
+          </a:prstGeom>
+          <a:noFill/>
+        </p:spPr>
+        <p:txBody>
+          <a:bodyPr wrap="square">
+            <a:spAutoFit/>
+          </a:bodyPr>
+          <a:lstStyle/>
+          <a:p>
+            <a:pPr algn="l">
+              <a:spcBef>
+                <a:spcPts val="0"/>
+              </a:spcBef>
+              <a:spcAft>
+                <a:spcPts val="600"/>
+              </a:spcAft>
+            </a:pPr>
+            <a:r>
+              <a:rPr sz="1250" b="0" i="1">
+                <a:solidFill>
+                  <a:srgbClr val="6B7A82"/>
+                </a:solidFill>
+                <a:latin typeface="Calibri"/>
+              </a:rPr>
+              <a:t>Feeds the SSc-vs-HC contrasts (M1 IFN p=3.2e-4 in skin) and the endotype workflow (per-cluster module fingerprints).</a:t>
+            </a:r>
+          </a:p>
+        </p:txBody>
+      </p:sp>
+      <p:sp>
+        <p:nvSpPr>
+          <p:cNvPr id="12" name="TextBox 11"/>
+          <p:cNvSpPr txBox="1"/>
+          <p:nvPr/>
+        </p:nvSpPr>
+        <p:spPr>
+          <a:xfrm>
+            <a:off x="548640" y="6437376"/>
+            <a:ext cx="8229600" cy="365760"/>
+          </a:xfrm>
+          <a:prstGeom prst="rect">
+            <a:avLst/>
+          </a:prstGeom>
+          <a:noFill/>
+        </p:spPr>
+        <p:txBody>
+          <a:bodyPr wrap="square">
+            <a:spAutoFit/>
+          </a:bodyPr>
+          <a:lstStyle/>
+          <a:p>
+            <a:pPr algn="l">
+              <a:spcBef>
+                <a:spcPts val="0"/>
+              </a:spcBef>
+              <a:spcAft>
+                <a:spcPts val="600"/>
+              </a:spcAft>
+            </a:pPr>
+            <a:r>
+              <a:rPr sz="900" b="0" i="0">
+                <a:solidFill>
+                  <a:srgbClr val="6B7A82"/>
+                </a:solidFill>
+                <a:latin typeface="Calibri"/>
+              </a:rPr>
+              <a:t>SSc-MIM · Construction, data &amp; validation</a:t>
+            </a:r>
+          </a:p>
+        </p:txBody>
+      </p:sp>
+      <p:sp>
+        <p:nvSpPr>
+          <p:cNvPr id="13" name="TextBox 12"/>
+          <p:cNvSpPr txBox="1"/>
+          <p:nvPr/>
+        </p:nvSpPr>
+        <p:spPr>
+          <a:xfrm>
+            <a:off x="11247120" y="6437376"/>
+            <a:ext cx="731520" cy="365760"/>
+          </a:xfrm>
+          <a:prstGeom prst="rect">
+            <a:avLst/>
+          </a:prstGeom>
+          <a:noFill/>
+        </p:spPr>
+        <p:txBody>
+          <a:bodyPr wrap="square">
+            <a:spAutoFit/>
+          </a:bodyPr>
+          <a:lstStyle/>
+          <a:p>
+            <a:pPr algn="r">
+              <a:spcBef>
+                <a:spcPts val="0"/>
+              </a:spcBef>
+              <a:spcAft>
+                <a:spcPts val="600"/>
+              </a:spcAft>
+            </a:pPr>
+            <a:r>
+              <a:rPr sz="1000" b="0" i="0">
+                <a:solidFill>
+                  <a:srgbClr val="6B7A82"/>
+                </a:solidFill>
+                <a:latin typeface="Calibri"/>
+              </a:rPr>
+              <a:t>15</a:t>
+            </a:r>
+          </a:p>
+        </p:txBody>
+      </p:sp>
+    </p:spTree>
+  </p:cSld>
+  <p:clrMapOvr>
+    <a:masterClrMapping/>
+  </p:clrMapOvr>
+</p:sld>
+</file>
+
+<file path=ppt/slides/slide16.xml><?xml version="1.0" encoding="utf-8"?>
+<p:sld xmlns:a="http://schemas.openxmlformats.org/drawingml/2006/main" xmlns:p="http://schemas.openxmlformats.org/presentationml/2006/main" xmlns:r="http://schemas.openxmlformats.org/officeDocument/2006/relationships">
+  <p:cSld>
+    <p:spTree>
+      <p:nvGrpSpPr>
+        <p:cNvPr id="1" name=""/>
+        <p:cNvGrpSpPr/>
+        <p:nvPr/>
+      </p:nvGrpSpPr>
+      <p:grpSpPr/>
+      <p:sp>
+        <p:nvSpPr>
+          <p:cNvPr id="2" name="Rectangle 1"/>
+          <p:cNvSpPr/>
+          <p:nvPr/>
+        </p:nvSpPr>
+        <p:spPr>
+          <a:xfrm>
+            <a:off x="0" y="0"/>
+            <a:ext cx="12191695" cy="6858000"/>
+          </a:xfrm>
+          <a:prstGeom prst="rect">
+            <a:avLst/>
+          </a:prstGeom>
+          <a:solidFill>
+            <a:srgbClr val="F6F4F0"/>
+          </a:solidFill>
+          <a:ln>
+            <a:noFill/>
+          </a:ln>
+          <a:effectLst/>
+        </p:spPr>
+        <p:style>
+          <a:lnRef idx="1">
+            <a:schemeClr val="accent1"/>
+          </a:lnRef>
+          <a:fillRef idx="3">
+            <a:schemeClr val="accent1"/>
+          </a:fillRef>
+          <a:effectRef idx="2">
+            <a:schemeClr val="accent1"/>
+          </a:effectRef>
+          <a:fontRef idx="minor">
+            <a:schemeClr val="lt1"/>
+          </a:fontRef>
+        </p:style>
+        <p:txBody>
+          <a:bodyPr rtlCol="0" anchor="ctr"/>
+          <a:lstStyle/>
+          <a:p>
+            <a:pPr algn="ctr"/>
+          </a:p>
+        </p:txBody>
+      </p:sp>
+      <p:sp>
+        <p:nvSpPr>
+          <p:cNvPr id="3" name="Rectangle 2"/>
+          <p:cNvSpPr/>
+          <p:nvPr/>
+        </p:nvSpPr>
+        <p:spPr>
+          <a:xfrm>
+            <a:off x="0" y="0"/>
+            <a:ext cx="12191695" cy="1078992"/>
+          </a:xfrm>
+          <a:prstGeom prst="rect">
+            <a:avLst/>
+          </a:prstGeom>
+          <a:solidFill>
+            <a:srgbClr val="142C3A"/>
+          </a:solidFill>
+          <a:ln>
+            <a:noFill/>
+          </a:ln>
+          <a:effectLst/>
+        </p:spPr>
+        <p:style>
+          <a:lnRef idx="1">
+            <a:schemeClr val="accent1"/>
+          </a:lnRef>
+          <a:fillRef idx="3">
+            <a:schemeClr val="accent1"/>
+          </a:fillRef>
+          <a:effectRef idx="2">
+            <a:schemeClr val="accent1"/>
+          </a:effectRef>
+          <a:fontRef idx="minor">
+            <a:schemeClr val="lt1"/>
+          </a:fontRef>
+        </p:style>
+        <p:txBody>
+          <a:bodyPr rtlCol="0" anchor="ctr"/>
+          <a:lstStyle/>
+          <a:p>
+            <a:pPr algn="ctr"/>
+          </a:p>
+        </p:txBody>
+      </p:sp>
+      <p:sp>
+        <p:nvSpPr>
+          <p:cNvPr id="4" name="Rectangle 3"/>
+          <p:cNvSpPr/>
+          <p:nvPr/>
+        </p:nvSpPr>
+        <p:spPr>
+          <a:xfrm>
+            <a:off x="0" y="1078992"/>
+            <a:ext cx="12191695" cy="54864"/>
+          </a:xfrm>
+          <a:prstGeom prst="rect">
+            <a:avLst/>
+          </a:prstGeom>
+          <a:solidFill>
+            <a:srgbClr val="2E8B9E"/>
+          </a:solidFill>
+          <a:ln>
+            <a:noFill/>
+          </a:ln>
+          <a:effectLst/>
+        </p:spPr>
+        <p:style>
+          <a:lnRef idx="1">
+            <a:schemeClr val="accent1"/>
+          </a:lnRef>
+          <a:fillRef idx="3">
+            <a:schemeClr val="accent1"/>
+          </a:fillRef>
+          <a:effectRef idx="2">
+            <a:schemeClr val="accent1"/>
+          </a:effectRef>
+          <a:fontRef idx="minor">
+            <a:schemeClr val="lt1"/>
+          </a:fontRef>
+        </p:style>
+        <p:txBody>
+          <a:bodyPr rtlCol="0" anchor="ctr"/>
+          <a:lstStyle/>
+          <a:p>
+            <a:pPr algn="ctr"/>
+          </a:p>
+        </p:txBody>
+      </p:sp>
+      <p:sp>
+        <p:nvSpPr>
+          <p:cNvPr id="5" name="TextBox 4"/>
+          <p:cNvSpPr txBox="1"/>
+          <p:nvPr/>
+        </p:nvSpPr>
+        <p:spPr>
+          <a:xfrm>
+            <a:off x="548640" y="109728"/>
+            <a:ext cx="11155680" cy="914400"/>
+          </a:xfrm>
+          <a:prstGeom prst="rect">
+            <a:avLst/>
+          </a:prstGeom>
+          <a:noFill/>
+        </p:spPr>
+        <p:txBody>
+          <a:bodyPr wrap="square">
+            <a:spAutoFit/>
+          </a:bodyPr>
+          <a:lstStyle/>
+          <a:p>
+            <a:pPr algn="l">
+              <a:spcBef>
+                <a:spcPts val="0"/>
+              </a:spcBef>
+              <a:spcAft>
+                <a:spcPts val="600"/>
+              </a:spcAft>
+            </a:pPr>
+            <a:r>
+              <a:rPr sz="1200" b="1" i="0">
+                <a:solidFill>
+                  <a:srgbClr val="2E8B9E"/>
+                </a:solidFill>
+                <a:latin typeface="Calibri"/>
+              </a:rPr>
+              <a:t>REPRODUCIBILITY</a:t>
+            </a:r>
+          </a:p>
+          <a:p>
+            <a:pPr algn="l">
+              <a:spcBef>
+                <a:spcPts val="100"/>
+              </a:spcBef>
+              <a:spcAft>
+                <a:spcPts val="600"/>
+              </a:spcAft>
+            </a:pPr>
+            <a:r>
+              <a:rPr sz="2500" b="1" i="0">
+                <a:solidFill>
+                  <a:srgbClr val="FFFFFF"/>
+                </a:solidFill>
+                <a:latin typeface="Calibri"/>
+              </a:rPr>
+              <a:t>Scripted, tested, containerised, citable</a:t>
+            </a:r>
+          </a:p>
+        </p:txBody>
+      </p:sp>
+      <p:sp>
+        <p:nvSpPr>
+          <p:cNvPr id="6" name="Rectangle 5"/>
+          <p:cNvSpPr/>
+          <p:nvPr/>
+        </p:nvSpPr>
+        <p:spPr>
+          <a:xfrm>
+            <a:off x="548640" y="1508760"/>
+            <a:ext cx="3611880" cy="2103120"/>
+          </a:xfrm>
+          <a:prstGeom prst="rect">
+            <a:avLst/>
+          </a:prstGeom>
+          <a:solidFill>
+            <a:srgbClr val="FFFFFF"/>
+          </a:solidFill>
+          <a:ln>
+            <a:noFill/>
+          </a:ln>
+          <a:effectLst/>
+        </p:spPr>
+        <p:style>
+          <a:lnRef idx="1">
+            <a:schemeClr val="accent1"/>
+          </a:lnRef>
+          <a:fillRef idx="3">
+            <a:schemeClr val="accent1"/>
+          </a:fillRef>
+          <a:effectRef idx="2">
+            <a:schemeClr val="accent1"/>
+          </a:effectRef>
+          <a:fontRef idx="minor">
+            <a:schemeClr val="lt1"/>
+          </a:fontRef>
+        </p:style>
+        <p:txBody>
+          <a:bodyPr rtlCol="0" anchor="ctr"/>
+          <a:lstStyle/>
+          <a:p>
+            <a:pPr algn="ctr"/>
+          </a:p>
+        </p:txBody>
+      </p:sp>
+      <p:sp>
+        <p:nvSpPr>
+          <p:cNvPr id="7" name="Rectangle 6"/>
+          <p:cNvSpPr/>
+          <p:nvPr/>
+        </p:nvSpPr>
+        <p:spPr>
+          <a:xfrm>
+            <a:off x="548640" y="1508760"/>
+            <a:ext cx="3611880" cy="73152"/>
+          </a:xfrm>
+          <a:prstGeom prst="rect">
+            <a:avLst/>
+          </a:prstGeom>
+          <a:solidFill>
+            <a:srgbClr val="3A73B8"/>
+          </a:solidFill>
+          <a:ln>
+            <a:noFill/>
+          </a:ln>
+          <a:effectLst/>
+        </p:spPr>
+        <p:style>
+          <a:lnRef idx="1">
+            <a:schemeClr val="accent1"/>
+          </a:lnRef>
+          <a:fillRef idx="3">
+            <a:schemeClr val="accent1"/>
+          </a:fillRef>
+          <a:effectRef idx="2">
+            <a:schemeClr val="accent1"/>
+          </a:effectRef>
+          <a:fontRef idx="minor">
+            <a:schemeClr val="lt1"/>
+          </a:fontRef>
+        </p:style>
+        <p:txBody>
+          <a:bodyPr rtlCol="0" anchor="ctr"/>
+          <a:lstStyle/>
+          <a:p>
+            <a:pPr algn="ctr"/>
+          </a:p>
+        </p:txBody>
+      </p:sp>
+      <p:sp>
+        <p:nvSpPr>
+          <p:cNvPr id="8" name="TextBox 7"/>
+          <p:cNvSpPr txBox="1"/>
+          <p:nvPr/>
+        </p:nvSpPr>
+        <p:spPr>
+          <a:xfrm>
+            <a:off x="749808" y="1673351"/>
+            <a:ext cx="3246120" cy="1828800"/>
+          </a:xfrm>
+          <a:prstGeom prst="rect">
+            <a:avLst/>
+          </a:prstGeom>
+          <a:noFill/>
+        </p:spPr>
+        <p:txBody>
+          <a:bodyPr wrap="square">
+            <a:spAutoFit/>
+          </a:bodyPr>
+          <a:lstStyle/>
+          <a:p>
+            <a:pPr algn="l">
+              <a:spcBef>
+                <a:spcPts val="0"/>
+              </a:spcBef>
+              <a:spcAft>
+                <a:spcPts val="500"/>
+              </a:spcAft>
+            </a:pPr>
+            <a:r>
+              <a:rPr sz="1500" b="1" i="0">
+                <a:solidFill>
+                  <a:srgbClr val="3A73B8"/>
+                </a:solidFill>
+                <a:latin typeface="Calibri"/>
+              </a:rPr>
+              <a:t>Scripted pipeline</a:t>
+            </a:r>
+          </a:p>
+          <a:p>
+            <a:pPr algn="l">
+              <a:spcBef>
+                <a:spcPts val="0"/>
+              </a:spcBef>
+              <a:spcAft>
+                <a:spcPts val="600"/>
+              </a:spcAft>
+            </a:pPr>
+            <a:r>
+              <a:rPr sz="1250" b="0" i="0">
+                <a:solidFill>
+                  <a:srgbClr val="223038"/>
+                </a:solidFill>
+                <a:latin typeface="Calibri"/>
+              </a:rPr>
+              <a:t>make auto runs the whole lane; make lint / validate run every content + SBML linter.</a:t>
+            </a:r>
+          </a:p>
+        </p:txBody>
+      </p:sp>
+      <p:sp>
+        <p:nvSpPr>
+          <p:cNvPr id="9" name="Rectangle 8"/>
+          <p:cNvSpPr/>
+          <p:nvPr/>
+        </p:nvSpPr>
+        <p:spPr>
+          <a:xfrm>
+            <a:off x="4315968" y="1508760"/>
+            <a:ext cx="3611880" cy="2103120"/>
+          </a:xfrm>
+          <a:prstGeom prst="rect">
+            <a:avLst/>
+          </a:prstGeom>
+          <a:solidFill>
+            <a:srgbClr val="FFFFFF"/>
+          </a:solidFill>
+          <a:ln>
+            <a:noFill/>
+          </a:ln>
+          <a:effectLst/>
+        </p:spPr>
+        <p:style>
+          <a:lnRef idx="1">
+            <a:schemeClr val="accent1"/>
+          </a:lnRef>
+          <a:fillRef idx="3">
+            <a:schemeClr val="accent1"/>
+          </a:fillRef>
+          <a:effectRef idx="2">
+            <a:schemeClr val="accent1"/>
+          </a:effectRef>
+          <a:fontRef idx="minor">
+            <a:schemeClr val="lt1"/>
+          </a:fontRef>
+        </p:style>
+        <p:txBody>
+          <a:bodyPr rtlCol="0" anchor="ctr"/>
+          <a:lstStyle/>
+          <a:p>
+            <a:pPr algn="ctr"/>
+          </a:p>
+        </p:txBody>
+      </p:sp>
+      <p:sp>
+        <p:nvSpPr>
+          <p:cNvPr id="10" name="Rectangle 9"/>
+          <p:cNvSpPr/>
+          <p:nvPr/>
+        </p:nvSpPr>
+        <p:spPr>
+          <a:xfrm>
+            <a:off x="4315968" y="1508760"/>
+            <a:ext cx="3611880" cy="73152"/>
+          </a:xfrm>
+          <a:prstGeom prst="rect">
+            <a:avLst/>
+          </a:prstGeom>
+          <a:solidFill>
+            <a:srgbClr val="3F9E8C"/>
+          </a:solidFill>
+          <a:ln>
+            <a:noFill/>
+          </a:ln>
+          <a:effectLst/>
+        </p:spPr>
+        <p:style>
+          <a:lnRef idx="1">
+            <a:schemeClr val="accent1"/>
+          </a:lnRef>
+          <a:fillRef idx="3">
+            <a:schemeClr val="accent1"/>
+          </a:fillRef>
+          <a:effectRef idx="2">
+            <a:schemeClr val="accent1"/>
+          </a:effectRef>
+          <a:fontRef idx="minor">
+            <a:schemeClr val="lt1"/>
+          </a:fontRef>
+        </p:style>
+        <p:txBody>
+          <a:bodyPr rtlCol="0" anchor="ctr"/>
+          <a:lstStyle/>
+          <a:p>
+            <a:pPr algn="ctr"/>
+          </a:p>
+        </p:txBody>
+      </p:sp>
+      <p:sp>
+        <p:nvSpPr>
+          <p:cNvPr id="11" name="TextBox 10"/>
+          <p:cNvSpPr txBox="1"/>
+          <p:nvPr/>
+        </p:nvSpPr>
+        <p:spPr>
+          <a:xfrm>
+            <a:off x="4517136" y="1673351"/>
+            <a:ext cx="3246120" cy="1828800"/>
+          </a:xfrm>
+          <a:prstGeom prst="rect">
+            <a:avLst/>
+          </a:prstGeom>
+          <a:noFill/>
+        </p:spPr>
+        <p:txBody>
+          <a:bodyPr wrap="square">
+            <a:spAutoFit/>
+          </a:bodyPr>
+          <a:lstStyle/>
+          <a:p>
+            <a:pPr algn="l">
+              <a:spcBef>
+                <a:spcPts val="0"/>
+              </a:spcBef>
+              <a:spcAft>
+                <a:spcPts val="500"/>
+              </a:spcAft>
+            </a:pPr>
+            <a:r>
+              <a:rPr sz="1500" b="1" i="0">
+                <a:solidFill>
+                  <a:srgbClr val="3F9E8C"/>
+                </a:solidFill>
+                <a:latin typeface="Calibri"/>
+              </a:rPr>
+              <a:t>Tested + CI</a:t>
+            </a:r>
+          </a:p>
+          <a:p>
+            <a:pPr algn="l">
+              <a:spcBef>
+                <a:spcPts val="0"/>
+              </a:spcBef>
+              <a:spcAft>
+                <a:spcPts val="600"/>
+              </a:spcAft>
+            </a:pPr>
+            <a:r>
+              <a:rPr sz="1250" b="0" i="0">
+                <a:solidFill>
+                  <a:srgbClr val="223038"/>
+                </a:solidFill>
+                <a:latin typeface="Calibri"/>
+              </a:rPr>
+              <a:t>pytest suite (no data needed); GitHub Actions: validate_sbml, lint, scripts-smoke, figures.</a:t>
+            </a:r>
+          </a:p>
+        </p:txBody>
+      </p:sp>
+      <p:sp>
+        <p:nvSpPr>
+          <p:cNvPr id="12" name="Rectangle 11"/>
+          <p:cNvSpPr/>
+          <p:nvPr/>
+        </p:nvSpPr>
+        <p:spPr>
+          <a:xfrm>
+            <a:off x="8083296" y="1508760"/>
+            <a:ext cx="3611880" cy="2103120"/>
+          </a:xfrm>
+          <a:prstGeom prst="rect">
+            <a:avLst/>
+          </a:prstGeom>
+          <a:solidFill>
+            <a:srgbClr val="FFFFFF"/>
+          </a:solidFill>
+          <a:ln>
+            <a:noFill/>
+          </a:ln>
+          <a:effectLst/>
+        </p:spPr>
+        <p:style>
+          <a:lnRef idx="1">
+            <a:schemeClr val="accent1"/>
+          </a:lnRef>
+          <a:fillRef idx="3">
+            <a:schemeClr val="accent1"/>
+          </a:fillRef>
+          <a:effectRef idx="2">
+            <a:schemeClr val="accent1"/>
+          </a:effectRef>
+          <a:fontRef idx="minor">
+            <a:schemeClr val="lt1"/>
+          </a:fontRef>
+        </p:style>
+        <p:txBody>
+          <a:bodyPr rtlCol="0" anchor="ctr"/>
+          <a:lstStyle/>
+          <a:p>
+            <a:pPr algn="ctr"/>
+          </a:p>
+        </p:txBody>
+      </p:sp>
+      <p:sp>
+        <p:nvSpPr>
+          <p:cNvPr id="13" name="Rectangle 12"/>
+          <p:cNvSpPr/>
+          <p:nvPr/>
+        </p:nvSpPr>
+        <p:spPr>
+          <a:xfrm>
+            <a:off x="8083296" y="1508760"/>
+            <a:ext cx="3611880" cy="73152"/>
+          </a:xfrm>
+          <a:prstGeom prst="rect">
+            <a:avLst/>
+          </a:prstGeom>
+          <a:solidFill>
+            <a:srgbClr val="2E8B9E"/>
+          </a:solidFill>
+          <a:ln>
+            <a:noFill/>
+          </a:ln>
+          <a:effectLst/>
+        </p:spPr>
+        <p:style>
+          <a:lnRef idx="1">
+            <a:schemeClr val="accent1"/>
+          </a:lnRef>
+          <a:fillRef idx="3">
+            <a:schemeClr val="accent1"/>
+          </a:fillRef>
+          <a:effectRef idx="2">
+            <a:schemeClr val="accent1"/>
+          </a:effectRef>
+          <a:fontRef idx="minor">
+            <a:schemeClr val="lt1"/>
+          </a:fontRef>
+        </p:style>
+        <p:txBody>
+          <a:bodyPr rtlCol="0" anchor="ctr"/>
+          <a:lstStyle/>
+          <a:p>
+            <a:pPr algn="ctr"/>
+          </a:p>
+        </p:txBody>
+      </p:sp>
+      <p:sp>
+        <p:nvSpPr>
+          <p:cNvPr id="14" name="TextBox 13"/>
+          <p:cNvSpPr txBox="1"/>
+          <p:nvPr/>
+        </p:nvSpPr>
+        <p:spPr>
+          <a:xfrm>
+            <a:off x="8284464" y="1673351"/>
+            <a:ext cx="3246120" cy="1828800"/>
+          </a:xfrm>
+          <a:prstGeom prst="rect">
+            <a:avLst/>
+          </a:prstGeom>
+          <a:noFill/>
+        </p:spPr>
+        <p:txBody>
+          <a:bodyPr wrap="square">
+            <a:spAutoFit/>
+          </a:bodyPr>
+          <a:lstStyle/>
+          <a:p>
+            <a:pPr algn="l">
+              <a:spcBef>
+                <a:spcPts val="0"/>
+              </a:spcBef>
+              <a:spcAft>
+                <a:spcPts val="500"/>
+              </a:spcAft>
+            </a:pPr>
+            <a:r>
+              <a:rPr sz="1500" b="1" i="0">
+                <a:solidFill>
+                  <a:srgbClr val="2E8B9E"/>
+                </a:solidFill>
+                <a:latin typeface="Calibri"/>
+              </a:rPr>
+              <a:t>Containerised</a:t>
+            </a:r>
+          </a:p>
+          <a:p>
+            <a:pPr algn="l">
+              <a:spcBef>
+                <a:spcPts val="0"/>
+              </a:spcBef>
+              <a:spcAft>
+                <a:spcPts val="600"/>
+              </a:spcAft>
+            </a:pPr>
+            <a:r>
+              <a:rPr sz="1250" b="0" i="0">
+                <a:solidFill>
+                  <a:srgbClr val="223038"/>
+                </a:solidFill>
+                <a:latin typeface="Calibri"/>
+              </a:rPr>
+              <a:t>Dockerfile + workflow pin the environment for end-to-end reproduction.</a:t>
+            </a:r>
+          </a:p>
+        </p:txBody>
+      </p:sp>
+      <p:sp>
+        <p:nvSpPr>
+          <p:cNvPr id="15" name="Rectangle 14"/>
+          <p:cNvSpPr/>
+          <p:nvPr/>
+        </p:nvSpPr>
+        <p:spPr>
+          <a:xfrm>
+            <a:off x="548640" y="3794760"/>
+            <a:ext cx="3611880" cy="2103120"/>
+          </a:xfrm>
+          <a:prstGeom prst="rect">
+            <a:avLst/>
+          </a:prstGeom>
+          <a:solidFill>
+            <a:srgbClr val="FFFFFF"/>
+          </a:solidFill>
+          <a:ln>
+            <a:noFill/>
+          </a:ln>
+          <a:effectLst/>
+        </p:spPr>
+        <p:style>
+          <a:lnRef idx="1">
+            <a:schemeClr val="accent1"/>
+          </a:lnRef>
+          <a:fillRef idx="3">
+            <a:schemeClr val="accent1"/>
+          </a:fillRef>
+          <a:effectRef idx="2">
+            <a:schemeClr val="accent1"/>
+          </a:effectRef>
+          <a:fontRef idx="minor">
+            <a:schemeClr val="lt1"/>
+          </a:fontRef>
+        </p:style>
+        <p:txBody>
+          <a:bodyPr rtlCol="0" anchor="ctr"/>
+          <a:lstStyle/>
+          <a:p>
+            <a:pPr algn="ctr"/>
+          </a:p>
+        </p:txBody>
+      </p:sp>
+      <p:sp>
+        <p:nvSpPr>
+          <p:cNvPr id="16" name="Rectangle 15"/>
+          <p:cNvSpPr/>
+          <p:nvPr/>
+        </p:nvSpPr>
+        <p:spPr>
+          <a:xfrm>
+            <a:off x="548640" y="3794760"/>
+            <a:ext cx="3611880" cy="73152"/>
+          </a:xfrm>
+          <a:prstGeom prst="rect">
+            <a:avLst/>
+          </a:prstGeom>
+          <a:solidFill>
+            <a:srgbClr val="7E5A9E"/>
+          </a:solidFill>
+          <a:ln>
+            <a:noFill/>
+          </a:ln>
+          <a:effectLst/>
+        </p:spPr>
+        <p:style>
+          <a:lnRef idx="1">
+            <a:schemeClr val="accent1"/>
+          </a:lnRef>
+          <a:fillRef idx="3">
+            <a:schemeClr val="accent1"/>
+          </a:fillRef>
+          <a:effectRef idx="2">
+            <a:schemeClr val="accent1"/>
+          </a:effectRef>
+          <a:fontRef idx="minor">
+            <a:schemeClr val="lt1"/>
+          </a:fontRef>
+        </p:style>
+        <p:txBody>
+          <a:bodyPr rtlCol="0" anchor="ctr"/>
+          <a:lstStyle/>
+          <a:p>
+            <a:pPr algn="ctr"/>
+          </a:p>
+        </p:txBody>
+      </p:sp>
+      <p:sp>
+        <p:nvSpPr>
+          <p:cNvPr id="17" name="TextBox 16"/>
+          <p:cNvSpPr txBox="1"/>
+          <p:nvPr/>
+        </p:nvSpPr>
+        <p:spPr>
+          <a:xfrm>
+            <a:off x="749808" y="3959352"/>
+            <a:ext cx="3246120" cy="1828800"/>
+          </a:xfrm>
+          <a:prstGeom prst="rect">
+            <a:avLst/>
+          </a:prstGeom>
+          <a:noFill/>
+        </p:spPr>
+        <p:txBody>
+          <a:bodyPr wrap="square">
+            <a:spAutoFit/>
+          </a:bodyPr>
+          <a:lstStyle/>
+          <a:p>
+            <a:pPr algn="l">
+              <a:spcBef>
+                <a:spcPts val="0"/>
+              </a:spcBef>
+              <a:spcAft>
+                <a:spcPts val="500"/>
+              </a:spcAft>
+            </a:pPr>
+            <a:r>
+              <a:rPr sz="1500" b="1" i="0">
+                <a:solidFill>
+                  <a:srgbClr val="7E5A9E"/>
+                </a:solidFill>
+                <a:latin typeface="Calibri"/>
+              </a:rPr>
+              <a:t>Provenance &amp; metadata</a:t>
+            </a:r>
+          </a:p>
+          <a:p>
+            <a:pPr algn="l">
+              <a:spcBef>
+                <a:spcPts val="0"/>
+              </a:spcBef>
+              <a:spcAft>
+                <a:spcPts val="600"/>
+              </a:spcAft>
+            </a:pPr>
+            <a:r>
+              <a:rPr sz="1250" b="0" i="0">
+                <a:solidFill>
+                  <a:srgbClr val="223038"/>
+                </a:solidFill>
+                <a:latin typeface="Calibri"/>
+              </a:rPr>
+              <a:t>RO-Crate manifest, MIRIAM injection for BioModels, CITATION.cff + .zenodo.json.</a:t>
+            </a:r>
+          </a:p>
+        </p:txBody>
+      </p:sp>
+      <p:sp>
+        <p:nvSpPr>
+          <p:cNvPr id="18" name="Rectangle 17"/>
+          <p:cNvSpPr/>
+          <p:nvPr/>
+        </p:nvSpPr>
+        <p:spPr>
+          <a:xfrm>
+            <a:off x="4315968" y="3794760"/>
+            <a:ext cx="3611880" cy="2103120"/>
+          </a:xfrm>
+          <a:prstGeom prst="rect">
+            <a:avLst/>
+          </a:prstGeom>
+          <a:solidFill>
+            <a:srgbClr val="FFFFFF"/>
+          </a:solidFill>
+          <a:ln>
+            <a:noFill/>
+          </a:ln>
+          <a:effectLst/>
+        </p:spPr>
+        <p:style>
+          <a:lnRef idx="1">
+            <a:schemeClr val="accent1"/>
+          </a:lnRef>
+          <a:fillRef idx="3">
+            <a:schemeClr val="accent1"/>
+          </a:fillRef>
+          <a:effectRef idx="2">
+            <a:schemeClr val="accent1"/>
+          </a:effectRef>
+          <a:fontRef idx="minor">
+            <a:schemeClr val="lt1"/>
+          </a:fontRef>
+        </p:style>
+        <p:txBody>
+          <a:bodyPr rtlCol="0" anchor="ctr"/>
+          <a:lstStyle/>
+          <a:p>
+            <a:pPr algn="ctr"/>
+          </a:p>
+        </p:txBody>
+      </p:sp>
+      <p:sp>
+        <p:nvSpPr>
+          <p:cNvPr id="19" name="Rectangle 18"/>
+          <p:cNvSpPr/>
+          <p:nvPr/>
+        </p:nvSpPr>
+        <p:spPr>
+          <a:xfrm>
+            <a:off x="4315968" y="3794760"/>
+            <a:ext cx="3611880" cy="73152"/>
+          </a:xfrm>
+          <a:prstGeom prst="rect">
+            <a:avLst/>
+          </a:prstGeom>
+          <a:solidFill>
+            <a:srgbClr val="E26D5A"/>
+          </a:solidFill>
+          <a:ln>
+            <a:noFill/>
+          </a:ln>
+          <a:effectLst/>
+        </p:spPr>
+        <p:style>
+          <a:lnRef idx="1">
+            <a:schemeClr val="accent1"/>
+          </a:lnRef>
+          <a:fillRef idx="3">
+            <a:schemeClr val="accent1"/>
+          </a:fillRef>
+          <a:effectRef idx="2">
+            <a:schemeClr val="accent1"/>
+          </a:effectRef>
+          <a:fontRef idx="minor">
+            <a:schemeClr val="lt1"/>
+          </a:fontRef>
+        </p:style>
+        <p:txBody>
+          <a:bodyPr rtlCol="0" anchor="ctr"/>
+          <a:lstStyle/>
+          <a:p>
+            <a:pPr algn="ctr"/>
+          </a:p>
+        </p:txBody>
+      </p:sp>
+      <p:sp>
+        <p:nvSpPr>
+          <p:cNvPr id="20" name="TextBox 19"/>
+          <p:cNvSpPr txBox="1"/>
+          <p:nvPr/>
+        </p:nvSpPr>
+        <p:spPr>
+          <a:xfrm>
+            <a:off x="4517136" y="3959352"/>
+            <a:ext cx="3246120" cy="1828800"/>
+          </a:xfrm>
+          <a:prstGeom prst="rect">
+            <a:avLst/>
+          </a:prstGeom>
+          <a:noFill/>
+        </p:spPr>
+        <p:txBody>
+          <a:bodyPr wrap="square">
+            <a:spAutoFit/>
+          </a:bodyPr>
+          <a:lstStyle/>
+          <a:p>
+            <a:pPr algn="l">
+              <a:spcBef>
+                <a:spcPts val="0"/>
+              </a:spcBef>
+              <a:spcAft>
+                <a:spcPts val="500"/>
+              </a:spcAft>
+            </a:pPr>
+            <a:r>
+              <a:rPr sz="1500" b="1" i="0">
+                <a:solidFill>
+                  <a:srgbClr val="E26D5A"/>
+                </a:solidFill>
+                <a:latin typeface="Calibri"/>
+              </a:rPr>
+              <a:t>Input-data mirror</a:t>
+            </a:r>
+          </a:p>
+          <a:p>
+            <a:pPr algn="l">
+              <a:spcBef>
+                <a:spcPts val="0"/>
+              </a:spcBef>
+              <a:spcAft>
+                <a:spcPts val="600"/>
+              </a:spcAft>
+            </a:pPr>
+            <a:r>
+              <a:rPr sz="1250" b="0" i="0">
+                <a:solidFill>
+                  <a:srgbClr val="223038"/>
+                </a:solidFill>
+                <a:latin typeface="Calibri"/>
+              </a:rPr>
+              <a:t>data/MIRROR.md + .sha256 — SHA-256-pinned GEO archives (Zenodo mirror).</a:t>
+            </a:r>
+          </a:p>
+        </p:txBody>
+      </p:sp>
+      <p:sp>
+        <p:nvSpPr>
+          <p:cNvPr id="21" name="Rectangle 20"/>
+          <p:cNvSpPr/>
+          <p:nvPr/>
+        </p:nvSpPr>
+        <p:spPr>
+          <a:xfrm>
+            <a:off x="8083296" y="3794760"/>
+            <a:ext cx="3611880" cy="2103120"/>
+          </a:xfrm>
+          <a:prstGeom prst="rect">
+            <a:avLst/>
+          </a:prstGeom>
+          <a:solidFill>
+            <a:srgbClr val="FFFFFF"/>
+          </a:solidFill>
+          <a:ln>
+            <a:noFill/>
+          </a:ln>
+          <a:effectLst/>
+        </p:spPr>
+        <p:style>
+          <a:lnRef idx="1">
+            <a:schemeClr val="accent1"/>
+          </a:lnRef>
+          <a:fillRef idx="3">
+            <a:schemeClr val="accent1"/>
+          </a:fillRef>
+          <a:effectRef idx="2">
+            <a:schemeClr val="accent1"/>
+          </a:effectRef>
+          <a:fontRef idx="minor">
+            <a:schemeClr val="lt1"/>
+          </a:fontRef>
+        </p:style>
+        <p:txBody>
+          <a:bodyPr rtlCol="0" anchor="ctr"/>
+          <a:lstStyle/>
+          <a:p>
+            <a:pPr algn="ctr"/>
+          </a:p>
+        </p:txBody>
+      </p:sp>
+      <p:sp>
+        <p:nvSpPr>
+          <p:cNvPr id="22" name="Rectangle 21"/>
+          <p:cNvSpPr/>
+          <p:nvPr/>
+        </p:nvSpPr>
+        <p:spPr>
+          <a:xfrm>
+            <a:off x="8083296" y="3794760"/>
+            <a:ext cx="3611880" cy="73152"/>
+          </a:xfrm>
+          <a:prstGeom prst="rect">
+            <a:avLst/>
+          </a:prstGeom>
+          <a:solidFill>
+            <a:srgbClr val="142C3A"/>
+          </a:solidFill>
+          <a:ln>
+            <a:noFill/>
+          </a:ln>
+          <a:effectLst/>
+        </p:spPr>
+        <p:style>
+          <a:lnRef idx="1">
+            <a:schemeClr val="accent1"/>
+          </a:lnRef>
+          <a:fillRef idx="3">
+            <a:schemeClr val="accent1"/>
+          </a:fillRef>
+          <a:effectRef idx="2">
+            <a:schemeClr val="accent1"/>
+          </a:effectRef>
+          <a:fontRef idx="minor">
+            <a:schemeClr val="lt1"/>
+          </a:fontRef>
+        </p:style>
+        <p:txBody>
+          <a:bodyPr rtlCol="0" anchor="ctr"/>
+          <a:lstStyle/>
+          <a:p>
+            <a:pPr algn="ctr"/>
+          </a:p>
+        </p:txBody>
+      </p:sp>
+      <p:sp>
+        <p:nvSpPr>
+          <p:cNvPr id="23" name="TextBox 22"/>
+          <p:cNvSpPr txBox="1"/>
+          <p:nvPr/>
+        </p:nvSpPr>
+        <p:spPr>
+          <a:xfrm>
+            <a:off x="8284464" y="3959352"/>
+            <a:ext cx="3246120" cy="1828800"/>
+          </a:xfrm>
+          <a:prstGeom prst="rect">
+            <a:avLst/>
+          </a:prstGeom>
+          <a:noFill/>
+        </p:spPr>
+        <p:txBody>
+          <a:bodyPr wrap="square">
+            <a:spAutoFit/>
+          </a:bodyPr>
+          <a:lstStyle/>
+          <a:p>
+            <a:pPr algn="l">
+              <a:spcBef>
+                <a:spcPts val="0"/>
+              </a:spcBef>
+              <a:spcAft>
+                <a:spcPts val="500"/>
+              </a:spcAft>
+            </a:pPr>
+            <a:r>
+              <a:rPr sz="1500" b="1" i="0">
+                <a:solidFill>
+                  <a:srgbClr val="142C3A"/>
+                </a:solidFill>
+                <a:latin typeface="Calibri"/>
+              </a:rPr>
+              <a:t>Release</a:t>
+            </a:r>
+          </a:p>
+          <a:p>
+            <a:pPr algn="l">
+              <a:spcBef>
+                <a:spcPts val="0"/>
+              </a:spcBef>
+              <a:spcAft>
+                <a:spcPts val="600"/>
+              </a:spcAft>
+            </a:pPr>
+            <a:r>
+              <a:rPr sz="1250" b="0" i="0">
+                <a:solidFill>
+                  <a:srgbClr val="223038"/>
+                </a:solidFill>
+                <a:latin typeface="Calibri"/>
+              </a:rPr>
+              <a:t>GitHub + Zenodo DOI at git tag v1.0; make release pre-flights.</a:t>
+            </a:r>
+          </a:p>
+        </p:txBody>
+      </p:sp>
+      <p:sp>
+        <p:nvSpPr>
+          <p:cNvPr id="24" name="TextBox 23"/>
+          <p:cNvSpPr txBox="1"/>
+          <p:nvPr/>
+        </p:nvSpPr>
+        <p:spPr>
+          <a:xfrm>
+            <a:off x="548640" y="6437376"/>
+            <a:ext cx="8229600" cy="365760"/>
+          </a:xfrm>
+          <a:prstGeom prst="rect">
+            <a:avLst/>
+          </a:prstGeom>
+          <a:noFill/>
+        </p:spPr>
+        <p:txBody>
+          <a:bodyPr wrap="square">
+            <a:spAutoFit/>
+          </a:bodyPr>
+          <a:lstStyle/>
+          <a:p>
+            <a:pPr algn="l">
+              <a:spcBef>
+                <a:spcPts val="0"/>
+              </a:spcBef>
+              <a:spcAft>
+                <a:spcPts val="600"/>
+              </a:spcAft>
+            </a:pPr>
+            <a:r>
+              <a:rPr sz="900" b="0" i="0">
+                <a:solidFill>
+                  <a:srgbClr val="6B7A82"/>
+                </a:solidFill>
+                <a:latin typeface="Calibri"/>
+              </a:rPr>
+              <a:t>SSc-MIM · Construction, data &amp; validation</a:t>
+            </a:r>
+          </a:p>
+        </p:txBody>
+      </p:sp>
+      <p:sp>
+        <p:nvSpPr>
+          <p:cNvPr id="25" name="TextBox 24"/>
+          <p:cNvSpPr txBox="1"/>
+          <p:nvPr/>
+        </p:nvSpPr>
+        <p:spPr>
+          <a:xfrm>
+            <a:off x="11247120" y="6437376"/>
+            <a:ext cx="731520" cy="365760"/>
+          </a:xfrm>
+          <a:prstGeom prst="rect">
+            <a:avLst/>
+          </a:prstGeom>
+          <a:noFill/>
+        </p:spPr>
+        <p:txBody>
+          <a:bodyPr wrap="square">
+            <a:spAutoFit/>
+          </a:bodyPr>
+          <a:lstStyle/>
+          <a:p>
+            <a:pPr algn="r">
+              <a:spcBef>
+                <a:spcPts val="0"/>
+              </a:spcBef>
+              <a:spcAft>
+                <a:spcPts val="600"/>
+              </a:spcAft>
+            </a:pPr>
+            <a:r>
+              <a:rPr sz="1000" b="0" i="0">
+                <a:solidFill>
+                  <a:srgbClr val="6B7A82"/>
+                </a:solidFill>
+                <a:latin typeface="Calibri"/>
+              </a:rPr>
+              <a:t>16</a:t>
+            </a:r>
+          </a:p>
+        </p:txBody>
+      </p:sp>
+    </p:spTree>
+  </p:cSld>
+  <p:clrMapOvr>
+    <a:masterClrMapping/>
+  </p:clrMapOvr>
+</p:sld>
+</file>
+
+<file path=ppt/slides/slide17.xml><?xml version="1.0" encoding="utf-8"?>
 <p:sld xmlns:a="http://schemas.openxmlformats.org/drawingml/2006/main" xmlns:p="http://schemas.openxmlformats.org/presentationml/2006/main" xmlns:r="http://schemas.openxmlformats.org/officeDocument/2006/relationships">
   <p:cSld>
     <p:spTree>

</xml_diff>

<commit_message>
docs: harmonise to six phenotype endpoints (incl. autoreactivity)
The map has 6 phenotype endpoint (sink) nodes, not 4. Harmonise all materials
to present them and surface SSc autoreactivity:
- four canonical biological sinks (myofibroblast activation, ECM/collagen
  deposition, vascular remodelling, type-I IFN/ISG signature)
- autoantibody production (autoreactivity, M4 output)
- skin severity (mRSS, clinical readout)

Updated README, the construction & validation reference doc, and all three
decks (general overview: 6-endpoint slide; construction & validation+endotypes:
architecture lines) + regenerated PDFs and the combined PDF. Endpoint table
with incoming-reaction counts added to the reference doc.

Co-Authored-By: Claude Opus 4.8 <noreply@anthropic.com>
</commit_message>
<xml_diff>
--- a/docs/SSc_MIM_construction_deck.pptx
+++ b/docs/SSc_MIM_construction_deck.pptx
@@ -12698,13 +12698,13 @@
               </a:spcAft>
             </a:pPr>
             <a:r>
-              <a:rPr sz="1350" b="1" i="0">
+              <a:rPr sz="1250" b="1" i="0">
                 <a:solidFill>
                   <a:srgbClr val="142C3A"/>
                 </a:solidFill>
                 <a:latin typeface="Calibri"/>
               </a:rPr>
-              <a:t>Four phenotype sinks (disease outputs): myofibroblast activation · ECM/collagen deposition · vascular remodelling · ISG signature.</a:t>
+              <a:t>Six phenotype endpoints (disease outputs): myofibroblast activation · ECM/collagen deposition · vascular remodelling · type-I IFN/ISG signature · autoantibody production (autoreactivity) · skin severity (mRSS).</a:t>
             </a:r>
           </a:p>
           <a:p>
@@ -12717,13 +12717,13 @@
               </a:spcAft>
             </a:pPr>
             <a:r>
-              <a:rPr sz="1250" b="0" i="0">
+              <a:rPr sz="1200" b="0" i="0">
                 <a:solidFill>
                   <a:srgbClr val="223038"/>
                 </a:solidFill>
                 <a:latin typeface="Calibri"/>
               </a:rPr>
-              <a:t>Modelling rule: every entity reaches a sink in ≤ 6 steps — verified, 0 violations (make sink-check).</a:t>
+              <a:t>Modelling rule: every entity reaches an endpoint in ≤ 6 steps — verified, 0 violations (make sink-check).</a:t>
             </a:r>
           </a:p>
         </p:txBody>

</xml_diff>

<commit_message>
docs+data: propagate 5-module map (M5 B-cell/autoreactivity) everywhere
Complete the M4->M4/M5 split across the whole resource:
- coverage_v1.1.json: add M5 (94%), update M4 (74%); overall 81.3% unchanged
  (relabelling doesn't change the detectable species set).
- regenerate canonical AUCell scores (5 modules) on the whole-tissue pseudobulk.
- new figure F7_M5_validation.png (+ generator) — internal B/plasma + GSE45536.
- README + reference doc: 5-module table, per-module counts (M4 11 / M5 10),
  coverage, M5 description + validation, autoreactivity endpoint -> M5.
- all three decks regenerated: general (5-module slide), construction
  (architecture), validation+endotypes (+ new M5 validation slide w/ F7);
  combined PDF rebuilt (52 pp).

Consistency verified across the 5 materials; no residual 4-module text.

Co-Authored-By: Claude Opus 4.8 <noreply@anthropic.com>
</commit_message>
<xml_diff>
--- a/docs/SSc_MIM_construction_deck.pptx
+++ b/docs/SSc_MIM_construction_deck.pptx
@@ -7719,7 +7719,7 @@
                 </a:solidFill>
                 <a:latin typeface="Calibri"/>
               </a:rPr>
-              <a:t>Per-module coverage: M1 84% · M2 88% · M3 75% · M4 71% · Tier-1 83%.</a:t>
+              <a:t>Per-module coverage: M1 84% · M2 88% · M3 75% · M4 74% · M5 94%.</a:t>
             </a:r>
           </a:p>
           <a:p>
@@ -12555,7 +12555,26 @@
                 </a:solidFill>
                 <a:latin typeface="Calibri"/>
               </a:rPr>
-              <a:t>M4 IL-6 / Th2 / B cells  ·  21</a:t>
+              <a:t>M4 Cytokines IL-6/IL-4/IL-13  ·  11</a:t>
+            </a:r>
+          </a:p>
+          <a:p>
+            <a:pPr algn="l">
+              <a:spcBef>
+                <a:spcPts val="0"/>
+              </a:spcBef>
+              <a:spcAft>
+                <a:spcPts val="500"/>
+              </a:spcAft>
+            </a:pPr>
+            <a:r>
+              <a:rPr sz="1350" b="1" i="0">
+                <a:solidFill>
+                  <a:srgbClr val="142C3A"/>
+                </a:solidFill>
+                <a:latin typeface="Calibri"/>
+              </a:rPr>
+              <a:t>M5 B-cell &amp; autoreactivity  ·  10</a:t>
             </a:r>
           </a:p>
           <a:p>

</xml_diff>